<commit_message>
Support redoing reports and robust GA4 date handling
Add a frontend 'Redo' action to regenerate a report with the same dates and show progress. Make GA4 snapshot navigation more robust by continuing when the summary card is absent and adding _ga4_dated_snapshot_url to force explicit date ranges when GA4 rewrites presets. Improve template picture mappings (bancabc) and avoid removing template-specific Picture 11. Capture only the Security Report Summary card for security header screenshots. Add a helper script to ensure templates end with Uptime and Recommendations, update PPTX templates, and add tests for the GA4 dated-URL behavior. Also include Playwright output artifacts.
</commit_message>
<xml_diff>
--- a/src/reports/report-templates/june-2026/bancabc-29-June-2026.pptx
+++ b/src/reports/report-templates/june-2026/bancabc-29-June-2026.pptx
@@ -5,23 +5,26 @@
     <p:sldMasterId id="2147483648" r:id="rId1"/>
   </p:sldMasterIdLst>
   <p:notesMasterIdLst>
-    <p:notesMasterId r:id="rId16"/>
+    <p:notesMasterId r:id="rId17"/>
   </p:notesMasterIdLst>
   <p:handoutMasterIdLst>
-    <p:handoutMasterId r:id="rId17"/>
+    <p:handoutMasterId r:id="rId18"/>
   </p:handoutMasterIdLst>
   <p:sldIdLst>
     <p:sldId id="256" r:id="rId3"/>
-    <p:sldId id="270" r:id="rId15"/>
+    <p:sldId id="270" r:id="rId4"/>
     <p:sldId id="265" r:id="rId5"/>
     <p:sldId id="258" r:id="rId6"/>
     <p:sldId id="259" r:id="rId7"/>
     <p:sldId id="260" r:id="rId8"/>
-    <p:sldId id="269" r:id="rId21"/>
-    <p:sldId id="261" r:id="rId9"/>
-    <p:sldId id="264" r:id="rId10"/>
-    <p:sldId id="266" r:id="rId11"/>
-    <p:sldId id="267" r:id="rId12"/>
+    <p:sldId id="269" r:id="rId9"/>
+    <p:sldId id="261" r:id="rId10"/>
+    <p:sldId id="264" r:id="rId11"/>
+    <p:sldId id="266" r:id="rId12"/>
+    <p:sldId id="267" r:id="rId13"/>
+    <p:sldId id="271" r:id="rId14"/>
+    <p:sldId id="272" r:id="rId15"/>
+    <p:sldId id="273" r:id="rId16"/>
   </p:sldIdLst>
   <p:sldSz cx="9144000" cy="5156200"/>
   <p:notesSz cx="9144000" cy="5156200"/>
@@ -1988,7 +1991,7 @@
                 <a:latin typeface="Raleway Regular" charset="0"/>
                 <a:cs typeface="Raleway Regular" charset="0"/>
               </a:rPr>
-              <a:t>June,2026</a:t>
+              <a:t>July,2026</a:t>
             </a:r>
             <a:endParaRPr sz="950" b="1" spc="-10" dirty="0">
               <a:solidFill>
@@ -2202,20 +2205,22 @@
       </p:grpSp>
       <p:pic>
         <p:nvPicPr>
-          <p:cNvPr id="12" name="object 12"/>
-          <p:cNvPicPr/>
+          <p:cNvPr id="13" name="Picture 12" descr="snapshot_card.png"/>
+          <p:cNvPicPr>
+            <a:picLocks noChangeAspect="1"/>
+          </p:cNvPicPr>
           <p:nvPr/>
         </p:nvPicPr>
         <p:blipFill>
-          <a:blip r:embed="rId3" cstate="print"/>
+          <a:blip r:embed="rId3"/>
           <a:stretch>
             <a:fillRect/>
           </a:stretch>
         </p:blipFill>
         <p:spPr>
           <a:xfrm>
-            <a:off x="71254" y="75596"/>
-            <a:ext cx="2628709" cy="415342"/>
+            <a:off x="5862955" y="1616075"/>
+            <a:ext cx="2924175" cy="2075180"/>
           </a:xfrm>
           <a:prstGeom prst="rect">
             <a:avLst/>
@@ -2224,7 +2229,7 @@
       </p:pic>
       <p:pic>
         <p:nvPicPr>
-          <p:cNvPr id="11" name="Picture 10" descr="Screenshot 2026-06-29 at 17.21.14"/>
+          <p:cNvPr id="14" name="Picture 13" descr="bancabc"/>
           <p:cNvPicPr>
             <a:picLocks noChangeAspect="1"/>
           </p:cNvPicPr>
@@ -2238,8 +2243,8 @@
         </p:blipFill>
         <p:spPr>
           <a:xfrm>
-            <a:off x="5862955" y="1616075"/>
-            <a:ext cx="2924175" cy="2075180"/>
+            <a:off x="0" y="0"/>
+            <a:ext cx="1964055" cy="1052830"/>
           </a:xfrm>
           <a:prstGeom prst="rect">
             <a:avLst/>
@@ -2513,7 +2518,7 @@
       </p:sp>
       <p:pic>
         <p:nvPicPr>
-          <p:cNvPr id="2" name="Picture 1" descr="Screenshot 2026-06-29 at 17.35.23"/>
+          <p:cNvPr id="7" name="Picture 6" descr="Screenshot 2026-07-28 at 09.01.38"/>
           <p:cNvPicPr>
             <a:picLocks noChangeAspect="1"/>
           </p:cNvPicPr>
@@ -2527,8 +2532,8 @@
         </p:blipFill>
         <p:spPr>
           <a:xfrm>
-            <a:off x="4038600" y="673100"/>
-            <a:ext cx="4966970" cy="3510915"/>
+            <a:off x="3962400" y="977900"/>
+            <a:ext cx="4834890" cy="3299460"/>
           </a:xfrm>
           <a:prstGeom prst="rect">
             <a:avLst/>
@@ -3159,32 +3164,8 @@
         </p:blipFill>
         <p:spPr>
           <a:xfrm>
-            <a:off x="4224020" y="977900"/>
+            <a:off x="4191000" y="1816100"/>
             <a:ext cx="4751070" cy="1216025"/>
-          </a:xfrm>
-          <a:prstGeom prst="rect">
-            <a:avLst/>
-          </a:prstGeom>
-        </p:spPr>
-      </p:pic>
-      <p:pic>
-        <p:nvPicPr>
-          <p:cNvPr id="15" name="Picture 14" descr="Screenshot 2026-05-28 at 11.32.25"/>
-          <p:cNvPicPr>
-            <a:picLocks noChangeAspect="1"/>
-          </p:cNvPicPr>
-          <p:nvPr/>
-        </p:nvPicPr>
-        <p:blipFill>
-          <a:blip r:embed="rId2"/>
-          <a:stretch>
-            <a:fillRect/>
-          </a:stretch>
-        </p:blipFill>
-        <p:spPr>
-          <a:xfrm>
-            <a:off x="4224020" y="2263140"/>
-            <a:ext cx="4718050" cy="2030095"/>
           </a:xfrm>
           <a:prstGeom prst="rect">
             <a:avLst/>
@@ -3200,7 +3181,878 @@
 </file>
 
 <file path=ppt/slides/slide12.xml><?xml version="1.0" encoding="utf-8"?>
-<p:sld xmlns:a="http://schemas.openxmlformats.org/drawingml/2006/main" xmlns:p="http://schemas.openxmlformats.org/presentationml/2006/main" xmlns:r="http://schemas.openxmlformats.org/officeDocument/2006/relationships">
+<p:sld xmlns:a="http://schemas.openxmlformats.org/drawingml/2006/main" xmlns:r="http://schemas.openxmlformats.org/officeDocument/2006/relationships" xmlns:p="http://schemas.openxmlformats.org/presentationml/2006/main">
+  <p:cSld>
+    <p:spTree>
+      <p:nvGrpSpPr>
+        <p:cNvPr id="1" name=""/>
+        <p:cNvGrpSpPr/>
+        <p:nvPr/>
+      </p:nvGrpSpPr>
+      <p:grpSpPr>
+        <a:xfrm>
+          <a:off x="0" y="0"/>
+          <a:ext cx="0" cy="0"/>
+          <a:chOff x="0" y="0"/>
+          <a:chExt cx="0" cy="0"/>
+        </a:xfrm>
+      </p:grpSpPr>
+      <p:sp>
+        <p:nvSpPr>
+          <p:cNvPr id="2" name="object 2"/>
+          <p:cNvSpPr/>
+          <p:nvPr/>
+        </p:nvSpPr>
+        <p:spPr>
+          <a:xfrm>
+            <a:off x="428625" y="428866"/>
+            <a:ext cx="57150" cy="609600"/>
+          </a:xfrm>
+          <a:custGeom>
+            <a:avLst/>
+            <a:gdLst/>
+            <a:ahLst/>
+            <a:cxnLst/>
+            <a:rect l="l" t="t" r="r" b="b"/>
+            <a:pathLst>
+              <a:path w="57150" h="609600">
+                <a:moveTo>
+                  <a:pt x="56756" y="0"/>
+                </a:moveTo>
+                <a:lnTo>
+                  <a:pt x="0" y="0"/>
+                </a:lnTo>
+                <a:lnTo>
+                  <a:pt x="0" y="609485"/>
+                </a:lnTo>
+                <a:lnTo>
+                  <a:pt x="56756" y="609485"/>
+                </a:lnTo>
+                <a:lnTo>
+                  <a:pt x="56756" y="0"/>
+                </a:lnTo>
+                <a:close/>
+              </a:path>
+            </a:pathLst>
+          </a:custGeom>
+          <a:solidFill>
+            <a:srgbClr val="1E3988"/>
+          </a:solidFill>
+        </p:spPr>
+        <p:txBody>
+          <a:bodyPr wrap="square" lIns="0" tIns="0" rIns="0" bIns="0" rtlCol="0"/>
+          <a:lstStyle/>
+          <a:p>
+            <a:endParaRPr>
+              <a:latin typeface="Raleway Regular" charset="0"/>
+              <a:cs typeface="Raleway Regular" charset="0"/>
+            </a:endParaRPr>
+          </a:p>
+        </p:txBody>
+      </p:sp>
+      <p:sp>
+        <p:nvSpPr>
+          <p:cNvPr id="3" name="object 3"/>
+          <p:cNvSpPr txBox="1">
+            <a:spLocks noGrp="1"/>
+          </p:cNvSpPr>
+          <p:nvPr>
+            <p:ph type="title"/>
+          </p:nvPr>
+        </p:nvSpPr>
+        <p:spPr>
+          <a:xfrm>
+            <a:off x="631190" y="381000"/>
+            <a:ext cx="3439795" cy="659130"/>
+          </a:xfrm>
+          <a:prstGeom prst="rect">
+            <a:avLst/>
+          </a:prstGeom>
+        </p:spPr>
+        <p:txBody>
+          <a:bodyPr vert="horz" wrap="square" lIns="0" tIns="13335" rIns="0" bIns="0" rtlCol="0">
+            <a:spAutoFit/>
+          </a:bodyPr>
+          <a:lstStyle/>
+          <a:p>
+            <a:pPr marL="12700">
+              <a:lnSpc>
+                <a:spcPct val="100000"/>
+              </a:lnSpc>
+              <a:spcBef>
+                <a:spcPts val="105"/>
+              </a:spcBef>
+            </a:pPr>
+            <a:r>
+              <a:rPr lang="en-US" dirty="0">
+                <a:latin typeface="Raleway Regular" charset="0"/>
+                <a:cs typeface="Raleway Regular" charset="0"/>
+              </a:rPr>
+              <a:t>Uptime and System Reliability Insight</a:t>
+            </a:r>
+            <a:endParaRPr lang="en-US" spc="-10" dirty="0">
+              <a:latin typeface="Raleway Regular" charset="0"/>
+              <a:cs typeface="Raleway Regular" charset="0"/>
+            </a:endParaRPr>
+          </a:p>
+        </p:txBody>
+      </p:sp>
+      <p:sp>
+        <p:nvSpPr>
+          <p:cNvPr id="5" name="object 5"/>
+          <p:cNvSpPr txBox="1"/>
+          <p:nvPr/>
+        </p:nvSpPr>
+        <p:spPr>
+          <a:xfrm>
+            <a:off x="305117" y="1434838"/>
+            <a:ext cx="3590925" cy="2216785"/>
+          </a:xfrm>
+          <a:prstGeom prst="rect">
+            <a:avLst/>
+          </a:prstGeom>
+          <a:solidFill>
+            <a:srgbClr val="F8F8FA"/>
+          </a:solidFill>
+          <a:ln w="9157">
+            <a:solidFill>
+              <a:srgbClr val="E0E8EE"/>
+            </a:solidFill>
+          </a:ln>
+        </p:spPr>
+        <p:txBody>
+          <a:bodyPr vert="horz" wrap="square" lIns="0" tIns="12065" rIns="0" bIns="0" rtlCol="0">
+            <a:spAutoFit/>
+          </a:bodyPr>
+          <a:lstStyle/>
+          <a:p>
+            <a:pPr marL="0" indent="0">
+              <a:lnSpc>
+                <a:spcPct val="100000"/>
+              </a:lnSpc>
+              <a:spcBef>
+                <a:spcPts val="95"/>
+              </a:spcBef>
+              <a:buFont typeface="Arial" panose="020B0704020202020204" pitchFamily="34" charset="0"/>
+              <a:buNone/>
+            </a:pPr>
+            <a:r>
+              <a:rPr lang="en-US" altLang="en-US" sz="950" dirty="0">
+                <a:solidFill>
+                  <a:srgbClr val="334153"/>
+                </a:solidFill>
+                <a:latin typeface="Raleway Regular" charset="0"/>
+                <a:cs typeface="Raleway Regular" charset="0"/>
+              </a:rPr>
+              <a:t>    ​</a:t>
+            </a:r>
+            <a:endParaRPr lang="en-US" altLang="en-US" sz="950" dirty="0">
+              <a:solidFill>
+                <a:srgbClr val="334153"/>
+              </a:solidFill>
+              <a:latin typeface="Raleway Regular" charset="0"/>
+              <a:cs typeface="Raleway Regular" charset="0"/>
+            </a:endParaRPr>
+          </a:p>
+          <a:p>
+            <a:pPr marL="0" indent="0">
+              <a:lnSpc>
+                <a:spcPct val="100000"/>
+              </a:lnSpc>
+              <a:spcBef>
+                <a:spcPts val="95"/>
+              </a:spcBef>
+              <a:buFont typeface="Arial" panose="020B0704020202020204" pitchFamily="34" charset="0"/>
+              <a:buNone/>
+            </a:pPr>
+            <a:endParaRPr lang="en-US" altLang="en-US" sz="950" dirty="0">
+              <a:solidFill>
+                <a:srgbClr val="334153"/>
+              </a:solidFill>
+              <a:latin typeface="Raleway Regular" charset="0"/>
+              <a:cs typeface="Raleway Regular" charset="0"/>
+            </a:endParaRPr>
+          </a:p>
+          <a:p>
+            <a:pPr marL="0" indent="0">
+              <a:lnSpc>
+                <a:spcPct val="100000"/>
+              </a:lnSpc>
+              <a:spcBef>
+                <a:spcPts val="95"/>
+              </a:spcBef>
+              <a:buFont typeface="Arial" panose="020B0704020202020204" pitchFamily="34" charset="0"/>
+              <a:buNone/>
+            </a:pPr>
+            <a:r>
+              <a:rPr lang="en-US" altLang="en-US" sz="950" dirty="0">
+                <a:solidFill>
+                  <a:srgbClr val="334153"/>
+                </a:solidFill>
+                <a:latin typeface="Raleway Regular" charset="0"/>
+                <a:cs typeface="Raleway Regular" charset="0"/>
+              </a:rPr>
+              <a:t>    The website demonstrates strong operational stability,</a:t>
+            </a:r>
+            <a:endParaRPr lang="en-US" altLang="en-US" sz="950" dirty="0">
+              <a:solidFill>
+                <a:srgbClr val="334153"/>
+              </a:solidFill>
+              <a:latin typeface="Raleway Regular" charset="0"/>
+              <a:cs typeface="Raleway Regular" charset="0"/>
+            </a:endParaRPr>
+          </a:p>
+          <a:p>
+            <a:pPr marL="0" indent="0">
+              <a:lnSpc>
+                <a:spcPct val="100000"/>
+              </a:lnSpc>
+              <a:spcBef>
+                <a:spcPts val="95"/>
+              </a:spcBef>
+              <a:buFont typeface="Arial" panose="020B0704020202020204" pitchFamily="34" charset="0"/>
+              <a:buNone/>
+            </a:pPr>
+            <a:r>
+              <a:rPr lang="en-US" altLang="en-US" sz="950" dirty="0">
+                <a:solidFill>
+                  <a:srgbClr val="334153"/>
+                </a:solidFill>
+                <a:latin typeface="Raleway Regular" charset="0"/>
+                <a:cs typeface="Raleway Regular" charset="0"/>
+              </a:rPr>
+              <a:t>    maintaining a 100% uptime over the past 24 hours and</a:t>
+            </a:r>
+            <a:endParaRPr lang="en-US" altLang="en-US" sz="950" dirty="0">
+              <a:solidFill>
+                <a:srgbClr val="334153"/>
+              </a:solidFill>
+              <a:latin typeface="Raleway Regular" charset="0"/>
+              <a:cs typeface="Raleway Regular" charset="0"/>
+            </a:endParaRPr>
+          </a:p>
+          <a:p>
+            <a:pPr marL="0" indent="0">
+              <a:lnSpc>
+                <a:spcPct val="100000"/>
+              </a:lnSpc>
+              <a:spcBef>
+                <a:spcPts val="95"/>
+              </a:spcBef>
+              <a:buFont typeface="Arial" panose="020B0704020202020204" pitchFamily="34" charset="0"/>
+              <a:buNone/>
+            </a:pPr>
+            <a:r>
+              <a:rPr lang="en-US" altLang="en-US" sz="950" dirty="0">
+                <a:solidFill>
+                  <a:srgbClr val="334153"/>
+                </a:solidFill>
+                <a:latin typeface="Raleway Regular" charset="0"/>
+                <a:cs typeface="Raleway Regular" charset="0"/>
+              </a:rPr>
+              <a:t>    100% uptime over the last 30 days, indicating highly</a:t>
+            </a:r>
+            <a:endParaRPr lang="en-US" altLang="en-US" sz="950" dirty="0">
+              <a:solidFill>
+                <a:srgbClr val="334153"/>
+              </a:solidFill>
+              <a:latin typeface="Raleway Regular" charset="0"/>
+              <a:cs typeface="Raleway Regular" charset="0"/>
+            </a:endParaRPr>
+          </a:p>
+          <a:p>
+            <a:pPr marL="0" indent="0">
+              <a:lnSpc>
+                <a:spcPct val="100000"/>
+              </a:lnSpc>
+              <a:spcBef>
+                <a:spcPts val="95"/>
+              </a:spcBef>
+              <a:buFont typeface="Arial" panose="020B0704020202020204" pitchFamily="34" charset="0"/>
+              <a:buNone/>
+            </a:pPr>
+            <a:r>
+              <a:rPr lang="en-US" altLang="en-US" sz="950" dirty="0">
+                <a:solidFill>
+                  <a:srgbClr val="334153"/>
+                </a:solidFill>
+                <a:latin typeface="Raleway Regular" charset="0"/>
+                <a:cs typeface="Raleway Regular" charset="0"/>
+              </a:rPr>
+              <a:t>    reliable service availability.​</a:t>
+            </a:r>
+            <a:endParaRPr lang="en-US" altLang="en-US" sz="950" dirty="0">
+              <a:solidFill>
+                <a:srgbClr val="334153"/>
+              </a:solidFill>
+              <a:latin typeface="Raleway Regular" charset="0"/>
+              <a:cs typeface="Raleway Regular" charset="0"/>
+            </a:endParaRPr>
+          </a:p>
+          <a:p>
+            <a:pPr marL="0" indent="0">
+              <a:lnSpc>
+                <a:spcPct val="100000"/>
+              </a:lnSpc>
+              <a:spcBef>
+                <a:spcPts val="95"/>
+              </a:spcBef>
+              <a:buFont typeface="Arial" panose="020B0704020202020204" pitchFamily="34" charset="0"/>
+              <a:buNone/>
+            </a:pPr>
+            <a:r>
+              <a:rPr lang="en-US" altLang="en-US" sz="950" dirty="0">
+                <a:solidFill>
+                  <a:srgbClr val="334153"/>
+                </a:solidFill>
+                <a:latin typeface="Raleway Regular" charset="0"/>
+                <a:cs typeface="Raleway Regular" charset="0"/>
+              </a:rPr>
+              <a:t>    The average response time of 1722ms reflects</a:t>
+            </a:r>
+            <a:endParaRPr lang="en-US" altLang="en-US" sz="950" dirty="0">
+              <a:solidFill>
+                <a:srgbClr val="334153"/>
+              </a:solidFill>
+              <a:latin typeface="Raleway Regular" charset="0"/>
+              <a:cs typeface="Raleway Regular" charset="0"/>
+            </a:endParaRPr>
+          </a:p>
+          <a:p>
+            <a:pPr marL="0" indent="0">
+              <a:lnSpc>
+                <a:spcPct val="100000"/>
+              </a:lnSpc>
+              <a:spcBef>
+                <a:spcPts val="95"/>
+              </a:spcBef>
+              <a:buFont typeface="Arial" panose="020B0704020202020204" pitchFamily="34" charset="0"/>
+              <a:buNone/>
+            </a:pPr>
+            <a:r>
+              <a:rPr lang="en-US" altLang="en-US" sz="950" dirty="0">
+                <a:solidFill>
+                  <a:srgbClr val="334153"/>
+                </a:solidFill>
+                <a:latin typeface="Raleway Regular" charset="0"/>
+                <a:cs typeface="Raleway Regular" charset="0"/>
+              </a:rPr>
+              <a:t>    acceptable performance, though there is an opportunity</a:t>
+            </a:r>
+            <a:endParaRPr lang="en-US" altLang="en-US" sz="950" dirty="0">
+              <a:solidFill>
+                <a:srgbClr val="334153"/>
+              </a:solidFill>
+              <a:latin typeface="Raleway Regular" charset="0"/>
+              <a:cs typeface="Raleway Regular" charset="0"/>
+            </a:endParaRPr>
+          </a:p>
+          <a:p>
+            <a:pPr marL="0" indent="0">
+              <a:lnSpc>
+                <a:spcPct val="100000"/>
+              </a:lnSpc>
+              <a:spcBef>
+                <a:spcPts val="95"/>
+              </a:spcBef>
+              <a:buFont typeface="Arial" panose="020B0704020202020204" pitchFamily="34" charset="0"/>
+              <a:buNone/>
+            </a:pPr>
+            <a:r>
+              <a:rPr lang="en-US" altLang="en-US" sz="950" dirty="0">
+                <a:solidFill>
+                  <a:srgbClr val="334153"/>
+                </a:solidFill>
+                <a:latin typeface="Raleway Regular" charset="0"/>
+                <a:cs typeface="Raleway Regular" charset="0"/>
+              </a:rPr>
+              <a:t>    to further optimize speed for an improved user</a:t>
+            </a:r>
+            <a:endParaRPr lang="en-US" altLang="en-US" sz="950" dirty="0">
+              <a:solidFill>
+                <a:srgbClr val="334153"/>
+              </a:solidFill>
+              <a:latin typeface="Raleway Regular" charset="0"/>
+              <a:cs typeface="Raleway Regular" charset="0"/>
+            </a:endParaRPr>
+          </a:p>
+          <a:p>
+            <a:pPr marL="0" indent="0">
+              <a:lnSpc>
+                <a:spcPct val="100000"/>
+              </a:lnSpc>
+              <a:spcBef>
+                <a:spcPts val="95"/>
+              </a:spcBef>
+              <a:buFont typeface="Arial" panose="020B0704020202020204" pitchFamily="34" charset="0"/>
+              <a:buNone/>
+            </a:pPr>
+            <a:r>
+              <a:rPr lang="en-US" altLang="en-US" sz="950" dirty="0">
+                <a:solidFill>
+                  <a:srgbClr val="334153"/>
+                </a:solidFill>
+                <a:latin typeface="Raleway Regular" charset="0"/>
+                <a:cs typeface="Raleway Regular" charset="0"/>
+              </a:rPr>
+              <a:t>    experience.​   ​</a:t>
+            </a:r>
+            <a:endParaRPr lang="en-US" altLang="en-US" sz="950" dirty="0">
+              <a:solidFill>
+                <a:srgbClr val="334153"/>
+              </a:solidFill>
+              <a:latin typeface="Raleway Regular" charset="0"/>
+              <a:cs typeface="Raleway Regular" charset="0"/>
+            </a:endParaRPr>
+          </a:p>
+          <a:p>
+            <a:pPr marL="0" indent="0">
+              <a:lnSpc>
+                <a:spcPct val="100000"/>
+              </a:lnSpc>
+              <a:spcBef>
+                <a:spcPts val="95"/>
+              </a:spcBef>
+              <a:buFont typeface="Arial" panose="020B0704020202020204" pitchFamily="34" charset="0"/>
+              <a:buNone/>
+            </a:pPr>
+            <a:r>
+              <a:rPr lang="en-US" altLang="en-US" sz="950" dirty="0">
+                <a:solidFill>
+                  <a:srgbClr val="334153"/>
+                </a:solidFill>
+                <a:latin typeface="Raleway Regular" charset="0"/>
+                <a:cs typeface="Raleway Regular" charset="0"/>
+              </a:rPr>
+              <a:t>    Overall, the system is stable, reliable, and performing</a:t>
+            </a:r>
+            <a:endParaRPr lang="en-US" altLang="en-US" sz="950" dirty="0">
+              <a:solidFill>
+                <a:srgbClr val="334153"/>
+              </a:solidFill>
+              <a:latin typeface="Raleway Regular" charset="0"/>
+              <a:cs typeface="Raleway Regular" charset="0"/>
+            </a:endParaRPr>
+          </a:p>
+          <a:p>
+            <a:pPr marL="0" indent="0">
+              <a:lnSpc>
+                <a:spcPct val="100000"/>
+              </a:lnSpc>
+              <a:spcBef>
+                <a:spcPts val="95"/>
+              </a:spcBef>
+              <a:buFont typeface="Arial" panose="020B0704020202020204" pitchFamily="34" charset="0"/>
+              <a:buNone/>
+            </a:pPr>
+            <a:r>
+              <a:rPr lang="en-US" altLang="en-US" sz="950" dirty="0">
+                <a:solidFill>
+                  <a:srgbClr val="334153"/>
+                </a:solidFill>
+                <a:latin typeface="Raleway Regular" charset="0"/>
+                <a:cs typeface="Raleway Regular" charset="0"/>
+              </a:rPr>
+              <a:t>    well, with minimal downtime and no active incidents.</a:t>
+            </a:r>
+            <a:endParaRPr lang="en-US" altLang="en-US" sz="950" dirty="0">
+              <a:solidFill>
+                <a:srgbClr val="334153"/>
+              </a:solidFill>
+              <a:latin typeface="Raleway Regular" charset="0"/>
+              <a:cs typeface="Raleway Regular" charset="0"/>
+            </a:endParaRPr>
+          </a:p>
+          <a:p>
+            <a:pPr marL="0" indent="0">
+              <a:lnSpc>
+                <a:spcPct val="100000"/>
+              </a:lnSpc>
+              <a:spcBef>
+                <a:spcPts val="95"/>
+              </a:spcBef>
+              <a:buFont typeface="Arial" panose="020B0704020202020204" pitchFamily="34" charset="0"/>
+              <a:buNone/>
+            </a:pPr>
+            <a:r>
+              <a:rPr lang="en-US" altLang="en-US" sz="950" dirty="0">
+                <a:solidFill>
+                  <a:srgbClr val="334153"/>
+                </a:solidFill>
+                <a:latin typeface="Raleway Regular" charset="0"/>
+                <a:cs typeface="Raleway Regular" charset="0"/>
+              </a:rPr>
+              <a:t>    Continued monitoring and performance optimization</a:t>
+            </a:r>
+            <a:endParaRPr lang="en-US" altLang="en-US" sz="950" dirty="0">
+              <a:solidFill>
+                <a:srgbClr val="334153"/>
+              </a:solidFill>
+              <a:latin typeface="Raleway Regular" charset="0"/>
+              <a:cs typeface="Raleway Regular" charset="0"/>
+            </a:endParaRPr>
+          </a:p>
+          <a:p>
+            <a:pPr marL="0" indent="0">
+              <a:lnSpc>
+                <a:spcPct val="100000"/>
+              </a:lnSpc>
+              <a:spcBef>
+                <a:spcPts val="95"/>
+              </a:spcBef>
+              <a:buFont typeface="Arial" panose="020B0704020202020204" pitchFamily="34" charset="0"/>
+              <a:buNone/>
+            </a:pPr>
+            <a:r>
+              <a:rPr lang="en-US" altLang="en-US" sz="950" dirty="0">
+                <a:solidFill>
+                  <a:srgbClr val="334153"/>
+                </a:solidFill>
+                <a:latin typeface="Raleway Regular" charset="0"/>
+                <a:cs typeface="Raleway Regular" charset="0"/>
+              </a:rPr>
+              <a:t>    will help maintain and further enhance service quality.​</a:t>
+            </a:r>
+            <a:endParaRPr lang="en-US" altLang="en-US" sz="950" dirty="0">
+              <a:solidFill>
+                <a:srgbClr val="334153"/>
+              </a:solidFill>
+              <a:latin typeface="Raleway Regular" charset="0"/>
+              <a:cs typeface="Raleway Regular" charset="0"/>
+            </a:endParaRPr>
+          </a:p>
+        </p:txBody>
+      </p:sp>
+      <p:pic>
+        <p:nvPicPr>
+          <p:cNvPr id="4" name="Picture 3" descr="Screenshot 2026-07-28 at 10.50.01"/>
+          <p:cNvPicPr>
+            <a:picLocks noChangeAspect="1"/>
+          </p:cNvPicPr>
+          <p:nvPr/>
+        </p:nvPicPr>
+        <p:blipFill>
+          <a:blip r:embed="rId1"/>
+          <a:stretch>
+            <a:fillRect/>
+          </a:stretch>
+        </p:blipFill>
+        <p:spPr>
+          <a:xfrm>
+            <a:off x="4191000" y="1739900"/>
+            <a:ext cx="4655820" cy="1724025"/>
+          </a:xfrm>
+          <a:prstGeom prst="rect">
+            <a:avLst/>
+          </a:prstGeom>
+        </p:spPr>
+      </p:pic>
+    </p:spTree>
+  </p:cSld>
+  <p:clrMapOvr>
+    <a:masterClrMapping/>
+  </p:clrMapOvr>
+</p:sld>
+</file>
+
+<file path=ppt/slides/slide13.xml><?xml version="1.0" encoding="utf-8"?>
+<p:sld xmlns:a="http://schemas.openxmlformats.org/drawingml/2006/main" xmlns:r="http://schemas.openxmlformats.org/officeDocument/2006/relationships" xmlns:p="http://schemas.openxmlformats.org/presentationml/2006/main">
+  <p:cSld>
+    <p:spTree>
+      <p:nvGrpSpPr>
+        <p:cNvPr id="1" name=""/>
+        <p:cNvGrpSpPr/>
+        <p:nvPr/>
+      </p:nvGrpSpPr>
+      <p:grpSpPr>
+        <a:xfrm>
+          <a:off x="0" y="0"/>
+          <a:ext cx="0" cy="0"/>
+          <a:chOff x="0" y="0"/>
+          <a:chExt cx="0" cy="0"/>
+        </a:xfrm>
+      </p:grpSpPr>
+      <p:sp>
+        <p:nvSpPr>
+          <p:cNvPr id="2" name="object 2"/>
+          <p:cNvSpPr txBox="1">
+            <a:spLocks noGrp="1"/>
+          </p:cNvSpPr>
+          <p:nvPr>
+            <p:ph type="title"/>
+          </p:nvPr>
+        </p:nvSpPr>
+        <p:spPr>
+          <a:xfrm>
+            <a:off x="401954" y="337185"/>
+            <a:ext cx="2235835" cy="346710"/>
+          </a:xfrm>
+          <a:prstGeom prst="rect">
+            <a:avLst/>
+          </a:prstGeom>
+        </p:spPr>
+        <p:txBody>
+          <a:bodyPr vert="horz" wrap="square" lIns="0" tIns="13335" rIns="0" bIns="0" rtlCol="0">
+            <a:spAutoFit/>
+          </a:bodyPr>
+          <a:lstStyle/>
+          <a:p>
+            <a:pPr marL="12700">
+              <a:lnSpc>
+                <a:spcPct val="100000"/>
+              </a:lnSpc>
+              <a:spcBef>
+                <a:spcPts val="105"/>
+              </a:spcBef>
+            </a:pPr>
+            <a:r>
+              <a:rPr spc="35" dirty="0"/>
+              <a:t>Recommendations</a:t>
+            </a:r>
+            <a:endParaRPr spc="35" dirty="0"/>
+          </a:p>
+        </p:txBody>
+      </p:sp>
+      <p:sp>
+        <p:nvSpPr>
+          <p:cNvPr id="3" name="object 3"/>
+          <p:cNvSpPr/>
+          <p:nvPr/>
+        </p:nvSpPr>
+        <p:spPr>
+          <a:xfrm>
+            <a:off x="285750" y="1229461"/>
+            <a:ext cx="4981575" cy="3469004"/>
+          </a:xfrm>
+          <a:custGeom>
+            <a:avLst/>
+            <a:gdLst/>
+            <a:ahLst/>
+            <a:cxnLst/>
+            <a:rect l="l" t="t" r="r" b="b"/>
+            <a:pathLst>
+              <a:path w="4981575" h="3469004">
+                <a:moveTo>
+                  <a:pt x="4981321" y="0"/>
+                </a:moveTo>
+                <a:lnTo>
+                  <a:pt x="0" y="0"/>
+                </a:lnTo>
+                <a:lnTo>
+                  <a:pt x="0" y="3468878"/>
+                </a:lnTo>
+                <a:lnTo>
+                  <a:pt x="4981321" y="3468878"/>
+                </a:lnTo>
+                <a:lnTo>
+                  <a:pt x="4981321" y="0"/>
+                </a:lnTo>
+                <a:close/>
+              </a:path>
+            </a:pathLst>
+          </a:custGeom>
+          <a:solidFill>
+            <a:srgbClr val="F8F8FA"/>
+          </a:solidFill>
+        </p:spPr>
+        <p:txBody>
+          <a:bodyPr wrap="square" lIns="0" tIns="0" rIns="0" bIns="0" rtlCol="0"/>
+          <a:lstStyle/>
+          <a:p/>
+        </p:txBody>
+      </p:sp>
+      <p:sp>
+        <p:nvSpPr>
+          <p:cNvPr id="5" name="object 5"/>
+          <p:cNvSpPr/>
+          <p:nvPr/>
+        </p:nvSpPr>
+        <p:spPr>
+          <a:xfrm>
+            <a:off x="85725" y="1229461"/>
+            <a:ext cx="28575" cy="3469004"/>
+          </a:xfrm>
+          <a:custGeom>
+            <a:avLst/>
+            <a:gdLst/>
+            <a:ahLst/>
+            <a:cxnLst/>
+            <a:rect l="l" t="t" r="r" b="b"/>
+            <a:pathLst>
+              <a:path w="28575" h="3469004">
+                <a:moveTo>
+                  <a:pt x="28054" y="0"/>
+                </a:moveTo>
+                <a:lnTo>
+                  <a:pt x="0" y="0"/>
+                </a:lnTo>
+                <a:lnTo>
+                  <a:pt x="0" y="3468878"/>
+                </a:lnTo>
+                <a:lnTo>
+                  <a:pt x="28054" y="3468878"/>
+                </a:lnTo>
+                <a:lnTo>
+                  <a:pt x="28054" y="0"/>
+                </a:lnTo>
+                <a:close/>
+              </a:path>
+            </a:pathLst>
+          </a:custGeom>
+          <a:solidFill>
+            <a:srgbClr val="1E3988"/>
+          </a:solidFill>
+        </p:spPr>
+        <p:txBody>
+          <a:bodyPr wrap="square" lIns="0" tIns="0" rIns="0" bIns="0" rtlCol="0"/>
+          <a:lstStyle/>
+          <a:p/>
+        </p:txBody>
+      </p:sp>
+      <p:sp>
+        <p:nvSpPr>
+          <p:cNvPr id="6" name="object 6"/>
+          <p:cNvSpPr/>
+          <p:nvPr/>
+        </p:nvSpPr>
+        <p:spPr>
+          <a:xfrm>
+            <a:off x="5486400" y="0"/>
+            <a:ext cx="3657600" cy="5153025"/>
+          </a:xfrm>
+          <a:custGeom>
+            <a:avLst/>
+            <a:gdLst/>
+            <a:ahLst/>
+            <a:cxnLst/>
+            <a:rect l="l" t="t" r="r" b="b"/>
+            <a:pathLst>
+              <a:path w="3657600" h="5153025">
+                <a:moveTo>
+                  <a:pt x="0" y="0"/>
+                </a:moveTo>
+                <a:lnTo>
+                  <a:pt x="0" y="5153025"/>
+                </a:lnTo>
+                <a:lnTo>
+                  <a:pt x="3657600" y="5153025"/>
+                </a:lnTo>
+                <a:lnTo>
+                  <a:pt x="3657600" y="0"/>
+                </a:lnTo>
+                <a:lnTo>
+                  <a:pt x="0" y="0"/>
+                </a:lnTo>
+                <a:close/>
+              </a:path>
+            </a:pathLst>
+          </a:custGeom>
+          <a:solidFill>
+            <a:srgbClr val="1E3988"/>
+          </a:solidFill>
+        </p:spPr>
+        <p:txBody>
+          <a:bodyPr wrap="square" lIns="0" tIns="0" rIns="0" bIns="0" rtlCol="0"/>
+          <a:lstStyle/>
+          <a:p/>
+        </p:txBody>
+      </p:sp>
+    </p:spTree>
+  </p:cSld>
+  <p:clrMapOvr>
+    <a:masterClrMapping/>
+  </p:clrMapOvr>
+</p:sld>
+</file>
+
+<file path=ppt/slides/slide14.xml><?xml version="1.0" encoding="utf-8"?>
+<p:sld xmlns:a="http://schemas.openxmlformats.org/drawingml/2006/main" xmlns:r="http://schemas.openxmlformats.org/officeDocument/2006/relationships" xmlns:p="http://schemas.openxmlformats.org/presentationml/2006/main">
+  <p:cSld>
+    <p:spTree>
+      <p:nvGrpSpPr>
+        <p:cNvPr id="1" name=""/>
+        <p:cNvGrpSpPr/>
+        <p:nvPr/>
+      </p:nvGrpSpPr>
+      <p:grpSpPr>
+        <a:xfrm>
+          <a:off x="0" y="0"/>
+          <a:ext cx="0" cy="0"/>
+          <a:chOff x="0" y="0"/>
+          <a:chExt cx="0" cy="0"/>
+        </a:xfrm>
+      </p:grpSpPr>
+      <p:sp>
+        <p:nvSpPr>
+          <p:cNvPr id="7" name="object 2"/>
+          <p:cNvSpPr txBox="1">
+            <a:spLocks noGrp="1"/>
+          </p:cNvSpPr>
+          <p:nvPr>
+            <p:ph type="title"/>
+          </p:nvPr>
+        </p:nvSpPr>
+        <p:spPr>
+          <a:xfrm>
+            <a:off x="2529839" y="1991741"/>
+            <a:ext cx="3992245" cy="850900"/>
+          </a:xfrm>
+          <a:prstGeom prst="rect">
+            <a:avLst/>
+          </a:prstGeom>
+        </p:spPr>
+        <p:txBody>
+          <a:bodyPr vert="horz" wrap="square" lIns="0" tIns="14604" rIns="0" bIns="0" rtlCol="0">
+            <a:spAutoFit/>
+          </a:bodyPr>
+          <a:lstStyle/>
+          <a:p>
+            <a:pPr marL="12700">
+              <a:lnSpc>
+                <a:spcPct val="100000"/>
+              </a:lnSpc>
+              <a:spcBef>
+                <a:spcPts val="115"/>
+              </a:spcBef>
+            </a:pPr>
+            <a:r>
+              <a:rPr sz="5400" spc="180" dirty="0">
+                <a:latin typeface="Trebuchet MS" panose="020B0603020202020204"/>
+                <a:cs typeface="Trebuchet MS" panose="020B0603020202020204"/>
+              </a:rPr>
+              <a:t>THANK</a:t>
+            </a:r>
+            <a:r>
+              <a:rPr sz="5400" spc="-40" dirty="0">
+                <a:latin typeface="Trebuchet MS" panose="020B0603020202020204"/>
+                <a:cs typeface="Trebuchet MS" panose="020B0603020202020204"/>
+              </a:rPr>
+              <a:t> </a:t>
+            </a:r>
+            <a:r>
+              <a:rPr sz="5400" spc="145" dirty="0">
+                <a:latin typeface="Trebuchet MS" panose="020B0603020202020204"/>
+                <a:cs typeface="Trebuchet MS" panose="020B0603020202020204"/>
+              </a:rPr>
+              <a:t>YOU</a:t>
+            </a:r>
+            <a:endParaRPr sz="5400">
+              <a:latin typeface="Trebuchet MS" panose="020B0603020202020204"/>
+              <a:cs typeface="Trebuchet MS" panose="020B0603020202020204"/>
+            </a:endParaRPr>
+          </a:p>
+        </p:txBody>
+      </p:sp>
+    </p:spTree>
+  </p:cSld>
+  <p:clrMapOvr>
+    <a:masterClrMapping/>
+  </p:clrMapOvr>
+</p:sld>
+</file>
+
+<file path=ppt/slides/slide2.xml><?xml version="1.0" encoding="utf-8"?>
+<p:sld xmlns:a="http://schemas.openxmlformats.org/drawingml/2006/main" xmlns:r="http://schemas.openxmlformats.org/officeDocument/2006/relationships" xmlns:p="http://schemas.openxmlformats.org/presentationml/2006/main">
   <p:cSld>
     <p:spTree>
       <p:nvGrpSpPr>
@@ -3558,6 +4410,41 @@
                 <a:tab pos="54610" algn="l"/>
               </a:tabLst>
             </a:pPr>
+            <a:r>
+              <a:rPr lang="en-US" altLang="en-US" sz="1200" spc="-10" dirty="0">
+                <a:latin typeface="Raleway Regular" charset="0"/>
+                <a:cs typeface="Raleway Regular" charset="0"/>
+              </a:rPr>
+              <a:t>This report aims to analyse the website’s performance for </a:t>
+            </a:r>
+            <a:r>
+              <a:rPr lang="en-US" altLang="en-US" sz="1200" b="1" spc="-10" dirty="0">
+                <a:latin typeface="Raleway Bold" charset="0"/>
+                <a:cs typeface="Raleway Bold" charset="0"/>
+              </a:rPr>
+              <a:t>July 2026</a:t>
+            </a:r>
+            <a:r>
+              <a:rPr lang="en-US" altLang="en-US" sz="1200" spc="-10" dirty="0">
+                <a:latin typeface="Raleway Regular" charset="0"/>
+                <a:cs typeface="Raleway Regular" charset="0"/>
+              </a:rPr>
+              <a:t>, focusing on traffic, user flow, demographics, behaviours and security. The wider scope covers the ongoing management, maintenance and optimisation of the </a:t>
+            </a:r>
+            <a:r>
+              <a:rPr lang="en-US" altLang="en-US" sz="1200" b="1" spc="-10" dirty="0">
+                <a:latin typeface="Raleway Bold" charset="0"/>
+                <a:cs typeface="Raleway Bold" charset="0"/>
+              </a:rPr>
+              <a:t>BancABC website</a:t>
+            </a:r>
+            <a:r>
+              <a:rPr lang="en-US" altLang="en-US" sz="1200" spc="-10" dirty="0">
+                <a:latin typeface="Raleway Regular" charset="0"/>
+                <a:cs typeface="Raleway Regular" charset="0"/>
+              </a:rPr>
+              <a:t> to ensure it remains secure, functional, updated and accessible. This includes CMS maintenance, plugin and theme updates, application-level security monitoring, backup oversight, performance and site health optimisation, technical SEO support, limited content and page updates, third-party integration monitoring, incident response, access governance, change management and monthly reporting. The service is focused on keeping the website stable and professionally managed, while ensuring key updates, risks, fixes and recommended actions are clearly documented.</a:t>
+            </a:r>
             <a:endParaRPr lang="en-US" altLang="en-US" sz="1200" spc="-10" dirty="0">
               <a:latin typeface="Raleway Regular" charset="0"/>
               <a:cs typeface="Raleway Regular" charset="0"/>
@@ -3775,27 +4662,7 @@
                 <a:latin typeface="Raleway Regular" charset="0"/>
                 <a:cs typeface="Raleway Regular" charset="0"/>
               </a:rPr>
-              <a:t>Performance Overview: </a:t>
-            </a:r>
-            <a:r>
-              <a:rPr lang="en-US" altLang="en-US" sz="1250" dirty="0">
-                <a:solidFill>
-                  <a:srgbClr val="334153"/>
-                </a:solidFill>
-                <a:latin typeface="Raleway Regular" charset="0"/>
-                <a:cs typeface="Raleway Regular" charset="0"/>
-              </a:rPr>
-              <a:t>85.5</a:t>
-            </a:r>
-            <a:r>
-              <a:rPr sz="1250" dirty="0">
-                <a:solidFill>
-                  <a:srgbClr val="334153"/>
-                </a:solidFill>
-                <a:latin typeface="Raleway Regular" charset="0"/>
-                <a:cs typeface="Raleway Regular" charset="0"/>
-              </a:rPr>
-              <a:t>% of users are first-time visitors</a:t>
+              <a:t>Performance overview shows 85.5% of users were first-time visitors.</a:t>
             </a:r>
             <a:endParaRPr sz="1250" dirty="0">
               <a:solidFill>
@@ -3941,7 +4808,7 @@
         <p:spPr>
           <a:xfrm>
             <a:off x="533514" y="1663763"/>
-            <a:ext cx="4610735" cy="1558925"/>
+            <a:ext cx="4610735" cy="626110"/>
           </a:xfrm>
           <a:prstGeom prst="rect">
             <a:avLst/>
@@ -3972,42 +4839,28 @@
                 <a:latin typeface="Raleway Regular" charset="0"/>
                 <a:cs typeface="Raleway Regular" charset="0"/>
               </a:rPr>
-              <a:t>The BancABC website delivered solid overall performance during the period under review, attracting </a:t>
-            </a:r>
-            <a:r>
-              <a:rPr lang="en-US" b="1" dirty="0">
-                <a:latin typeface="Raleway Regular" charset="0"/>
-                <a:cs typeface="Raleway Regular" charset="0"/>
-              </a:rPr>
-              <a:t>6.2</a:t>
+              <a:t>During the reporting period, the BancABC website attracted </a:t>
             </a:r>
             <a:r>
               <a:rPr b="1" dirty="0">
                 <a:latin typeface="Raleway Regular" charset="0"/>
                 <a:cs typeface="Raleway Regular" charset="0"/>
               </a:rPr>
-              <a:t>K</a:t>
+              <a:t>6.9K</a:t>
             </a:r>
             <a:r>
               <a:rPr dirty="0">
                 <a:latin typeface="Raleway Regular" charset="0"/>
                 <a:cs typeface="Raleway Regular" charset="0"/>
               </a:rPr>
-              <a:t> active users, of which </a:t>
-            </a:r>
-            <a:r>
-              <a:rPr lang="en-US" b="1" dirty="0">
-                <a:latin typeface="Raleway Regular" charset="0"/>
-                <a:cs typeface="Raleway Regular" charset="0"/>
-              </a:rPr>
-              <a:t>5.3</a:t>
+              <a:t> active users, including </a:t>
             </a:r>
             <a:r>
               <a:rPr b="1" dirty="0">
                 <a:latin typeface="Raleway Regular" charset="0"/>
                 <a:cs typeface="Raleway Regular" charset="0"/>
               </a:rPr>
-              <a:t>K</a:t>
+              <a:t>5.9K</a:t>
             </a:r>
             <a:r>
               <a:rPr dirty="0">
@@ -4017,91 +4870,20 @@
               <a:t> (</a:t>
             </a:r>
             <a:r>
-              <a:rPr lang="en-US" b="1" dirty="0">
-                <a:latin typeface="Raleway Bold" charset="0"/>
-                <a:cs typeface="Raleway Bold" charset="0"/>
-              </a:rPr>
-              <a:t>85.5</a:t>
-            </a:r>
-            <a:r>
               <a:rPr b="1" dirty="0">
                 <a:latin typeface="Raleway Regular" charset="0"/>
                 <a:cs typeface="Raleway Regular" charset="0"/>
               </a:rPr>
-              <a:t>%</a:t>
+              <a:t>85.5%</a:t>
             </a:r>
             <a:r>
               <a:rPr dirty="0">
                 <a:latin typeface="Raleway Regular" charset="0"/>
                 <a:cs typeface="Raleway Regular" charset="0"/>
               </a:rPr>
-              <a:t>) were new visitors. This strong proportion of first-time users reflects effective audience acquisition and sustained brand visibility across digital channels.</a:t>
-            </a:r>
-            <a:endParaRPr dirty="0">
-              <a:latin typeface="Raleway Regular" charset="0"/>
-              <a:cs typeface="Raleway Regular" charset="0"/>
-            </a:endParaRPr>
-          </a:p>
-          <a:p>
-            <a:pPr marL="11430" marR="457835" indent="-6985" algn="just">
-              <a:lnSpc>
-                <a:spcPct val="106000"/>
-              </a:lnSpc>
-              <a:buSzPct val="89000"/>
-              <a:buFont typeface="Arial MT"/>
-              <a:buChar char="•"/>
-              <a:tabLst>
-                <a:tab pos="54610" algn="l"/>
-              </a:tabLst>
-            </a:pPr>
-            <a:r>
-              <a:rPr dirty="0">
-                <a:latin typeface="Raleway Regular" charset="0"/>
-                <a:cs typeface="Raleway Regular" charset="0"/>
-              </a:rPr>
-              <a:t>The average engagement time of </a:t>
-            </a:r>
-            <a:r>
-              <a:rPr lang="en-US" b="1" dirty="0">
-                <a:latin typeface="Raleway Bold" charset="0"/>
-                <a:cs typeface="Raleway Bold" charset="0"/>
-              </a:rPr>
-              <a:t>59</a:t>
-            </a:r>
-            <a:r>
-              <a:rPr b="1" dirty="0">
-                <a:latin typeface="Raleway Regular" charset="0"/>
-                <a:cs typeface="Raleway Regular" charset="0"/>
-              </a:rPr>
-              <a:t>s</a:t>
-            </a:r>
-            <a:r>
-              <a:rPr dirty="0">
-                <a:latin typeface="Raleway Regular" charset="0"/>
-                <a:cs typeface="Raleway Regular" charset="0"/>
-              </a:rPr>
-              <a:t> indicates meaningful interaction with the content. Users who visit the platform are spending time engaging rather than immediately exiting, which reflects relevant and compelling content despite the size of the audience.</a:t>
-            </a:r>
-            <a:endParaRPr dirty="0">
-              <a:latin typeface="Raleway Regular" charset="0"/>
-              <a:cs typeface="Raleway Regular" charset="0"/>
-            </a:endParaRPr>
-          </a:p>
-          <a:p>
-            <a:pPr>
-              <a:lnSpc>
-                <a:spcPct val="100000"/>
-              </a:lnSpc>
-              <a:spcBef>
-                <a:spcPts val="110"/>
-              </a:spcBef>
-              <a:buClr>
-                <a:srgbClr val="334153"/>
-              </a:buClr>
-              <a:buFont typeface="Arial MT"/>
-              <a:buChar char="•"/>
-            </a:pPr>
-            <a:endParaRPr spc="-10" dirty="0">
+              <a:t>) new visitors. This audience mix reflects the website's continued ability to reach and attract new users across digital channels.</a:t>
+            </a:r>
+            <a:endParaRPr lang="en-US" spc="-10" dirty="0">
               <a:latin typeface="Raleway Regular" charset="0"/>
               <a:cs typeface="Raleway Regular" charset="0"/>
             </a:endParaRPr>
@@ -4148,19 +4930,9 @@
                 <a:latin typeface="Raleway Regular" charset="0"/>
                 <a:cs typeface="Raleway Regular" charset="0"/>
               </a:rPr>
-              <a:t>6.2</a:t>
-            </a:r>
-            <a:r>
-              <a:rPr sz="1800" b="1" spc="-25" dirty="0">
-                <a:solidFill>
-                  <a:srgbClr val="FFFFFF"/>
-                </a:solidFill>
-                <a:latin typeface="Raleway Regular" charset="0"/>
-                <a:cs typeface="Raleway Regular" charset="0"/>
-              </a:rPr>
-              <a:t>K</a:t>
-            </a:r>
-            <a:endParaRPr sz="1800" b="1" spc="-25" dirty="0">
+              <a:t>6.9K</a:t>
+            </a:r>
+            <a:endParaRPr lang="en-US" altLang="en-US" sz="1800" b="1" spc="-25" dirty="0">
               <a:solidFill>
                 <a:srgbClr val="FFFFFF"/>
               </a:solidFill>
@@ -4254,19 +5026,9 @@
                 <a:latin typeface="Raleway Regular" charset="0"/>
                 <a:cs typeface="Raleway Regular" charset="0"/>
               </a:rPr>
-              <a:t>85.5</a:t>
-            </a:r>
-            <a:r>
-              <a:rPr sz="1800" b="1" spc="-10" dirty="0">
-                <a:solidFill>
-                  <a:srgbClr val="FFFFFF"/>
-                </a:solidFill>
-                <a:latin typeface="Raleway Regular" charset="0"/>
-                <a:cs typeface="Raleway Regular" charset="0"/>
-              </a:rPr>
-              <a:t>%</a:t>
-            </a:r>
-            <a:endParaRPr sz="1800" b="1" spc="-10" dirty="0">
+              <a:t>85.5%</a:t>
+            </a:r>
+            <a:endParaRPr lang="en-US" altLang="en-US" sz="1800" b="1" spc="-10" dirty="0">
               <a:solidFill>
                 <a:srgbClr val="FFFFFF"/>
               </a:solidFill>
@@ -4380,7 +5142,7 @@
                 <a:latin typeface="Raleway Regular" charset="0"/>
                 <a:cs typeface="Raleway Regular" charset="0"/>
               </a:rPr>
-              <a:t>6.8%</a:t>
+              <a:t>7.6%</a:t>
             </a:r>
             <a:endParaRPr lang="en-US" altLang="en-US" sz="1800" b="1" spc="-20" dirty="0">
               <a:solidFill>
@@ -4517,27 +5279,7 @@
                 <a:latin typeface="Raleway Regular" charset="0"/>
                 <a:cs typeface="Raleway Regular" charset="0"/>
               </a:rPr>
-              <a:t>User Engagement Metrics: </a:t>
-            </a:r>
-            <a:r>
-              <a:rPr lang="en-US" sz="1250" b="0" dirty="0">
-                <a:solidFill>
-                  <a:srgbClr val="334153"/>
-                </a:solidFill>
-                <a:latin typeface="Raleway Regular" charset="0"/>
-                <a:cs typeface="Raleway Regular" charset="0"/>
-              </a:rPr>
-              <a:t>6.2</a:t>
-            </a:r>
-            <a:r>
-              <a:rPr sz="1250" b="0" dirty="0">
-                <a:solidFill>
-                  <a:srgbClr val="334153"/>
-                </a:solidFill>
-                <a:latin typeface="Raleway Regular" charset="0"/>
-                <a:cs typeface="Raleway Regular" charset="0"/>
-              </a:rPr>
-              <a:t>K Strong Active User Baseline</a:t>
+              <a:t>Engagement metrics confirm a 6.9K strong active user baseline.</a:t>
             </a:r>
             <a:endParaRPr sz="1250" b="0" dirty="0">
               <a:solidFill>
@@ -4707,19 +5449,9 @@
                 <a:latin typeface="Raleway Regular" charset="0"/>
                 <a:cs typeface="Raleway Regular" charset="0"/>
               </a:rPr>
-              <a:t>6.2</a:t>
-            </a:r>
-            <a:r>
-              <a:rPr sz="2450" b="1" spc="-10" dirty="0">
-                <a:solidFill>
-                  <a:srgbClr val="1E3988"/>
-                </a:solidFill>
-                <a:latin typeface="Raleway Regular" charset="0"/>
-                <a:cs typeface="Raleway Regular" charset="0"/>
-              </a:rPr>
-              <a:t>K</a:t>
-            </a:r>
-            <a:endParaRPr sz="2450" b="1" spc="-10" dirty="0">
+              <a:t>6.9K</a:t>
+            </a:r>
+            <a:endParaRPr lang="en-US" altLang="en-US" sz="2450" b="1" spc="-10" dirty="0">
               <a:solidFill>
                 <a:srgbClr val="1E3988"/>
               </a:solidFill>
@@ -4941,19 +5673,9 @@
                 <a:latin typeface="Raleway Regular" charset="0"/>
                 <a:cs typeface="Raleway Regular" charset="0"/>
               </a:rPr>
-              <a:t>5.3</a:t>
-            </a:r>
-            <a:r>
-              <a:rPr sz="2450" b="1" spc="-10" dirty="0">
-                <a:solidFill>
-                  <a:srgbClr val="1E3988"/>
-                </a:solidFill>
-                <a:latin typeface="Raleway Regular" charset="0"/>
-                <a:cs typeface="Raleway Regular" charset="0"/>
-              </a:rPr>
-              <a:t>K</a:t>
-            </a:r>
-            <a:endParaRPr sz="2450" b="1" spc="-10" dirty="0">
+              <a:t>5.9K</a:t>
+            </a:r>
+            <a:endParaRPr lang="en-US" altLang="en-US" sz="2450" b="1" spc="-10" dirty="0">
               <a:solidFill>
                 <a:srgbClr val="1E3988"/>
               </a:solidFill>
@@ -4978,27 +5700,7 @@
                 <a:latin typeface="Raleway Regular" charset="0"/>
                 <a:cs typeface="Raleway Regular" charset="0"/>
               </a:rPr>
-              <a:t>New Users (</a:t>
-            </a:r>
-            <a:r>
-              <a:rPr lang="en-US" altLang="en-US" sz="800" b="1" dirty="0">
-                <a:solidFill>
-                  <a:srgbClr val="627489"/>
-                </a:solidFill>
-                <a:latin typeface="Raleway Regular" charset="0"/>
-                <a:cs typeface="Raleway Regular" charset="0"/>
-              </a:rPr>
-              <a:t>85.5</a:t>
-            </a:r>
-            <a:r>
-              <a:rPr sz="800" b="1" dirty="0">
-                <a:solidFill>
-                  <a:srgbClr val="627489"/>
-                </a:solidFill>
-                <a:latin typeface="Raleway Regular" charset="0"/>
-                <a:cs typeface="Raleway Regular" charset="0"/>
-              </a:rPr>
-              <a:t>%)</a:t>
+              <a:t>New Users (85.5%)</a:t>
             </a:r>
             <a:endParaRPr sz="800" b="1" dirty="0">
               <a:solidFill>
@@ -5168,7 +5870,7 @@
                 <a:latin typeface="Raleway Regular" charset="0"/>
                 <a:cs typeface="Raleway Regular" charset="0"/>
               </a:rPr>
-              <a:t>59s</a:t>
+              <a:t>52s</a:t>
             </a:r>
             <a:endParaRPr lang="en-US" altLang="en-US" sz="2450" b="1" spc="-25" dirty="0">
               <a:solidFill>
@@ -5308,7 +6010,7 @@
         <p:spPr>
           <a:xfrm>
             <a:off x="421957" y="2182431"/>
-            <a:ext cx="3803650" cy="1765300"/>
+            <a:ext cx="3803650" cy="838200"/>
           </a:xfrm>
           <a:prstGeom prst="rect">
             <a:avLst/>
@@ -5342,17 +6044,7 @@
                 <a:latin typeface="Raleway Regular" charset="0"/>
                 <a:cs typeface="Raleway Regular" charset="0"/>
               </a:rPr>
-              <a:t>The reporting period reflects solid and encouraging performance for the BancABC website, with a total of </a:t>
-            </a:r>
-            <a:r>
-              <a:rPr lang="en-US" altLang="en-US" sz="950" b="1" dirty="0">
-                <a:solidFill>
-                  <a:srgbClr val="334153"/>
-                </a:solidFill>
-                <a:latin typeface="Raleway Bold" charset="0"/>
-                <a:cs typeface="Raleway Bold" charset="0"/>
-              </a:rPr>
-              <a:t>6.2</a:t>
+              <a:t>The BancABC website demonstrated robust performance this period, recording </a:t>
             </a:r>
             <a:r>
               <a:rPr sz="950" b="1" dirty="0">
@@ -5362,7 +6054,7 @@
                 <a:latin typeface="Raleway Regular" charset="0"/>
                 <a:cs typeface="Raleway Regular" charset="0"/>
               </a:rPr>
-              <a:t>K</a:t>
+              <a:t>6.9K</a:t>
             </a:r>
             <a:r>
               <a:rPr sz="950" dirty="0">
@@ -5372,17 +6064,7 @@
                 <a:latin typeface="Raleway Regular" charset="0"/>
                 <a:cs typeface="Raleway Regular" charset="0"/>
               </a:rPr>
-              <a:t> active users recorded during the period. Of these, </a:t>
-            </a:r>
-            <a:r>
-              <a:rPr lang="en-US" altLang="en-US" sz="950" b="1" dirty="0">
-                <a:solidFill>
-                  <a:srgbClr val="334153"/>
-                </a:solidFill>
-                <a:latin typeface="Raleway Bold" charset="0"/>
-                <a:cs typeface="Raleway Bold" charset="0"/>
-              </a:rPr>
-              <a:t>5.3</a:t>
+              <a:t> active users. Notably, </a:t>
             </a:r>
             <a:r>
               <a:rPr sz="950" b="1" dirty="0">
@@ -5392,7 +6074,7 @@
                 <a:latin typeface="Raleway Regular" charset="0"/>
                 <a:cs typeface="Raleway Regular" charset="0"/>
               </a:rPr>
-              <a:t>K</a:t>
+              <a:t>5.9K</a:t>
             </a:r>
             <a:r>
               <a:rPr sz="950" dirty="0">
@@ -5405,16 +6087,6 @@
               <a:t> users (</a:t>
             </a:r>
             <a:r>
-              <a:rPr lang="en-US" altLang="en-US" sz="950" b="1" dirty="0">
-                <a:solidFill>
-                  <a:srgbClr val="334153"/>
-                </a:solidFill>
-                <a:latin typeface="Raleway Bold" charset="0"/>
-                <a:cs typeface="Raleway Bold" charset="0"/>
-              </a:rPr>
-              <a:t>85.5</a:t>
-            </a:r>
-            <a:r>
               <a:rPr sz="950" b="1" dirty="0">
                 <a:solidFill>
                   <a:srgbClr val="334153"/>
@@ -5422,7 +6094,7 @@
                 <a:latin typeface="Raleway Regular" charset="0"/>
                 <a:cs typeface="Raleway Regular" charset="0"/>
               </a:rPr>
-              <a:t>%</a:t>
+              <a:t>85.5%</a:t>
             </a:r>
             <a:r>
               <a:rPr sz="950" dirty="0">
@@ -5432,61 +6104,7 @@
                 <a:latin typeface="Raleway Regular" charset="0"/>
                 <a:cs typeface="Raleway Regular" charset="0"/>
               </a:rPr>
-              <a:t>) were new visitors, highlighting continued strong brand discovery and the effectiveness of current reach and awareness initiatives.</a:t>
-            </a:r>
-            <a:endParaRPr sz="950" dirty="0">
-              <a:solidFill>
-                <a:srgbClr val="334153"/>
-              </a:solidFill>
-              <a:latin typeface="Raleway Regular" charset="0"/>
-              <a:cs typeface="Raleway Regular" charset="0"/>
-            </a:endParaRPr>
-          </a:p>
-          <a:p>
-            <a:pPr marL="12700" marR="29210">
-              <a:lnSpc>
-                <a:spcPct val="106000"/>
-              </a:lnSpc>
-            </a:pPr>
-            <a:r>
-              <a:rPr sz="950" dirty="0">
-                <a:solidFill>
-                  <a:srgbClr val="334153"/>
-                </a:solidFill>
-                <a:latin typeface="Raleway Regular" charset="0"/>
-                <a:cs typeface="Raleway Regular" charset="0"/>
-              </a:rPr>
-              <a:t>The average engagement time of </a:t>
-            </a:r>
-            <a:r>
-              <a:rPr lang="en-US" altLang="en-US" sz="950" b="1" dirty="0">
-                <a:solidFill>
-                  <a:srgbClr val="334153"/>
-                </a:solidFill>
-                <a:latin typeface="Raleway Bold" charset="0"/>
-                <a:cs typeface="Raleway Bold" charset="0"/>
-              </a:rPr>
-              <a:t>59</a:t>
-            </a:r>
-            <a:r>
-              <a:rPr sz="950" b="1" dirty="0">
-                <a:solidFill>
-                  <a:srgbClr val="334153"/>
-                </a:solidFill>
-                <a:latin typeface="Raleway Regular" charset="0"/>
-                <a:cs typeface="Raleway Regular" charset="0"/>
-              </a:rPr>
-              <a:t>s</a:t>
-            </a:r>
-            <a:r>
-              <a:rPr sz="950" dirty="0">
-                <a:solidFill>
-                  <a:srgbClr val="334153"/>
-                </a:solidFill>
-                <a:latin typeface="Raleway Regular" charset="0"/>
-                <a:cs typeface="Raleway Regular" charset="0"/>
-              </a:rPr>
-              <a:t> demonstrates moderate but meaningful interaction. While slightly below longer-form corporate engagement benchmarks, this duration suggests that users are spending enough time to review key information rather than exiting immediately.</a:t>
+              <a:t>) were new visitors, underscoring sustained brand visibility and the effectiveness of ongoing reach and awareness initiatives.</a:t>
             </a:r>
             <a:endParaRPr sz="950" dirty="0">
               <a:solidFill>
@@ -5646,7 +6264,7 @@
       </p:grpSp>
       <p:pic>
         <p:nvPicPr>
-          <p:cNvPr id="21" name="Picture 20" descr="Screenshot 2026-06-29 at 17.21.14"/>
+          <p:cNvPr id="20" name="Picture 19" descr="snapshot_card.png"/>
           <p:cNvPicPr>
             <a:picLocks noChangeAspect="1"/>
           </p:cNvPicPr>
@@ -5769,7 +6387,7 @@
                 <a:latin typeface="Raleway Regular" charset="0"/>
                 <a:cs typeface="Raleway Regular" charset="0"/>
               </a:rPr>
-              <a:t>Zimbabwe's Market Leadership and Global Opportunities.</a:t>
+              <a:t>Zimbabwe Dominates; International Opportunities Emerge.</a:t>
             </a:r>
             <a:endParaRPr sz="1250" b="0" dirty="0">
               <a:solidFill>
@@ -5944,7 +6562,107 @@
                 <a:latin typeface="Raleway Regular" charset="0"/>
                 <a:cs typeface="Raleway Regular" charset="0"/>
               </a:rPr>
-              <a:t>Zimbabwe is the dominant market in geographic performance, contributing 4,237 users (68.88% of total traffic). It maintains a 45.16% engagement rate and 1.16 engaged sessions per user, demonstrating strong volume with steady interaction.</a:t>
+              <a:t>Geographic performance confirms </a:t>
+            </a:r>
+            <a:r>
+              <a:rPr lang="en-US" altLang="en-US" sz="900" b="1" dirty="0">
+                <a:solidFill>
+                  <a:srgbClr val="334153"/>
+                </a:solidFill>
+                <a:latin typeface="Raleway Regular" charset="0"/>
+                <a:cs typeface="Raleway Regular" charset="0"/>
+              </a:rPr>
+              <a:t>Zimbabwe</a:t>
+            </a:r>
+            <a:r>
+              <a:rPr lang="en-US" altLang="en-US" sz="900" dirty="0">
+                <a:solidFill>
+                  <a:srgbClr val="334153"/>
+                </a:solidFill>
+                <a:latin typeface="Raleway Regular" charset="0"/>
+                <a:cs typeface="Raleway Regular" charset="0"/>
+              </a:rPr>
+              <a:t> as the primary market, contributing </a:t>
+            </a:r>
+            <a:r>
+              <a:rPr lang="en-US" altLang="en-US" sz="900" b="1" dirty="0">
+                <a:solidFill>
+                  <a:srgbClr val="334153"/>
+                </a:solidFill>
+                <a:latin typeface="Raleway Regular" charset="0"/>
+                <a:cs typeface="Raleway Regular" charset="0"/>
+              </a:rPr>
+              <a:t>4,800</a:t>
+            </a:r>
+            <a:r>
+              <a:rPr lang="en-US" altLang="en-US" sz="900" dirty="0">
+                <a:solidFill>
+                  <a:srgbClr val="334153"/>
+                </a:solidFill>
+                <a:latin typeface="Raleway Regular" charset="0"/>
+                <a:cs typeface="Raleway Regular" charset="0"/>
+              </a:rPr>
+              <a:t> users (</a:t>
+            </a:r>
+            <a:r>
+              <a:rPr lang="en-US" altLang="en-US" sz="900" b="1" dirty="0">
+                <a:solidFill>
+                  <a:srgbClr val="334153"/>
+                </a:solidFill>
+                <a:latin typeface="Raleway Regular" charset="0"/>
+                <a:cs typeface="Raleway Regular" charset="0"/>
+              </a:rPr>
+              <a:t>73.59%</a:t>
+            </a:r>
+            <a:r>
+              <a:rPr lang="en-US" altLang="en-US" sz="900" dirty="0">
+                <a:solidFill>
+                  <a:srgbClr val="334153"/>
+                </a:solidFill>
+                <a:latin typeface="Raleway Regular" charset="0"/>
+                <a:cs typeface="Raleway Regular" charset="0"/>
+              </a:rPr>
+              <a:t> of total traffic) with a </a:t>
+            </a:r>
+            <a:r>
+              <a:rPr lang="en-US" altLang="en-US" sz="900" b="1" dirty="0">
+                <a:solidFill>
+                  <a:srgbClr val="334153"/>
+                </a:solidFill>
+                <a:latin typeface="Raleway Regular" charset="0"/>
+                <a:cs typeface="Raleway Regular" charset="0"/>
+              </a:rPr>
+              <a:t>42.97%</a:t>
+            </a:r>
+            <a:r>
+              <a:rPr lang="en-US" altLang="en-US" sz="900" dirty="0">
+                <a:solidFill>
+                  <a:srgbClr val="334153"/>
+                </a:solidFill>
+                <a:latin typeface="Raleway Regular" charset="0"/>
+                <a:cs typeface="Raleway Regular" charset="0"/>
+              </a:rPr>
+              <a:t> engagement rate and </a:t>
+            </a:r>
+            <a:r>
+              <a:rPr lang="en-US" altLang="en-US" sz="900" b="1" dirty="0">
+                <a:solidFill>
+                  <a:srgbClr val="334153"/>
+                </a:solidFill>
+                <a:latin typeface="Raleway Regular" charset="0"/>
+                <a:cs typeface="Raleway Regular" charset="0"/>
+              </a:rPr>
+              <a:t>1.03</a:t>
+            </a:r>
+            <a:r>
+              <a:rPr lang="en-US" altLang="en-US" sz="900" dirty="0">
+                <a:solidFill>
+                  <a:srgbClr val="334153"/>
+                </a:solidFill>
+                <a:latin typeface="Raleway Regular" charset="0"/>
+                <a:cs typeface="Raleway Regular" charset="0"/>
+              </a:rPr>
+              <a:t> engaged sessions per user, delivering substantial volume and consistent interaction.</a:t>
             </a:r>
             <a:endParaRPr lang="en-US" altLang="en-US" sz="900" dirty="0">
               <a:solidFill>
@@ -5991,6 +6709,16 @@
               </a:tabLst>
             </a:pPr>
             <a:r>
+              <a:rPr lang="en-US" altLang="en-US" sz="900" b="1" dirty="0">
+                <a:solidFill>
+                  <a:srgbClr val="334153"/>
+                </a:solidFill>
+                <a:latin typeface="Raleway Regular" charset="0"/>
+                <a:cs typeface="Raleway Regular" charset="0"/>
+              </a:rPr>
+              <a:t>United States</a:t>
+            </a:r>
+            <a:r>
               <a:rPr lang="en-US" altLang="en-US" sz="900" dirty="0">
                 <a:solidFill>
                   <a:srgbClr val="334153"/>
@@ -5998,7 +6726,107 @@
                 <a:latin typeface="Raleway Regular" charset="0"/>
                 <a:cs typeface="Raleway Regular" charset="0"/>
               </a:rPr>
-              <a:t>The United States (872 users) records an 11.03% engagement rate, while Singapore (134 users) records a 2.22% engagement rate, indicating lower visit quality despite their international traffic volumes.</a:t>
+              <a:t> (</a:t>
+            </a:r>
+            <a:r>
+              <a:rPr lang="en-US" altLang="en-US" sz="900" b="1" dirty="0">
+                <a:solidFill>
+                  <a:srgbClr val="334153"/>
+                </a:solidFill>
+                <a:latin typeface="Raleway Regular" charset="0"/>
+                <a:cs typeface="Raleway Regular" charset="0"/>
+              </a:rPr>
+              <a:t>677</a:t>
+            </a:r>
+            <a:r>
+              <a:rPr lang="en-US" altLang="en-US" sz="900" dirty="0">
+                <a:solidFill>
+                  <a:srgbClr val="334153"/>
+                </a:solidFill>
+                <a:latin typeface="Raleway Regular" charset="0"/>
+                <a:cs typeface="Raleway Regular" charset="0"/>
+              </a:rPr>
+              <a:t> users) registers a </a:t>
+            </a:r>
+            <a:r>
+              <a:rPr lang="en-US" altLang="en-US" sz="900" b="1" dirty="0">
+                <a:solidFill>
+                  <a:srgbClr val="334153"/>
+                </a:solidFill>
+                <a:latin typeface="Raleway Regular" charset="0"/>
+                <a:cs typeface="Raleway Regular" charset="0"/>
+              </a:rPr>
+              <a:t>15.09%</a:t>
+            </a:r>
+            <a:r>
+              <a:rPr lang="en-US" altLang="en-US" sz="900" dirty="0">
+                <a:solidFill>
+                  <a:srgbClr val="334153"/>
+                </a:solidFill>
+                <a:latin typeface="Raleway Regular" charset="0"/>
+                <a:cs typeface="Raleway Regular" charset="0"/>
+              </a:rPr>
+              <a:t> engagement rate, whereas </a:t>
+            </a:r>
+            <a:r>
+              <a:rPr lang="en-US" altLang="en-US" sz="900" b="1" dirty="0">
+                <a:solidFill>
+                  <a:srgbClr val="334153"/>
+                </a:solidFill>
+                <a:latin typeface="Raleway Regular" charset="0"/>
+                <a:cs typeface="Raleway Regular" charset="0"/>
+              </a:rPr>
+              <a:t>South Africa</a:t>
+            </a:r>
+            <a:r>
+              <a:rPr lang="en-US" altLang="en-US" sz="900" dirty="0">
+                <a:solidFill>
+                  <a:srgbClr val="334153"/>
+                </a:solidFill>
+                <a:latin typeface="Raleway Regular" charset="0"/>
+                <a:cs typeface="Raleway Regular" charset="0"/>
+              </a:rPr>
+              <a:t> (</a:t>
+            </a:r>
+            <a:r>
+              <a:rPr lang="en-US" altLang="en-US" sz="900" b="1" dirty="0">
+                <a:solidFill>
+                  <a:srgbClr val="334153"/>
+                </a:solidFill>
+                <a:latin typeface="Raleway Regular" charset="0"/>
+                <a:cs typeface="Raleway Regular" charset="0"/>
+              </a:rPr>
+              <a:t>298</a:t>
+            </a:r>
+            <a:r>
+              <a:rPr lang="en-US" altLang="en-US" sz="900" dirty="0">
+                <a:solidFill>
+                  <a:srgbClr val="334153"/>
+                </a:solidFill>
+                <a:latin typeface="Raleway Regular" charset="0"/>
+                <a:cs typeface="Raleway Regular" charset="0"/>
+              </a:rPr>
+              <a:t> users) achieves a </a:t>
+            </a:r>
+            <a:r>
+              <a:rPr lang="en-US" altLang="en-US" sz="900" b="1" dirty="0">
+                <a:solidFill>
+                  <a:srgbClr val="334153"/>
+                </a:solidFill>
+                <a:latin typeface="Raleway Regular" charset="0"/>
+                <a:cs typeface="Raleway Regular" charset="0"/>
+              </a:rPr>
+              <a:t>54.03%</a:t>
+            </a:r>
+            <a:r>
+              <a:rPr lang="en-US" altLang="en-US" sz="900" dirty="0">
+                <a:solidFill>
+                  <a:srgbClr val="334153"/>
+                </a:solidFill>
+                <a:latin typeface="Raleway Regular" charset="0"/>
+                <a:cs typeface="Raleway Regular" charset="0"/>
+              </a:rPr>
+              <a:t> engagement rate, reflecting stronger visit quality despite lower traffic volumes.</a:t>
             </a:r>
             <a:endParaRPr lang="en-US" altLang="en-US" sz="900" dirty="0">
               <a:solidFill>
@@ -6052,7 +6880,47 @@
                 <a:latin typeface="Raleway Regular" charset="0"/>
                 <a:cs typeface="Raleway Regular" charset="0"/>
               </a:rPr>
-              <a:t>Notably, markets such as South Africa (57.29%), the United Kingdom (56.33%), Zambia (54.90%), and the Netherlands (51.19%) show the strongest engagement efficiency, indicating high-intent audiences.</a:t>
+              <a:t>Specifically, smaller markets such as </a:t>
+            </a:r>
+            <a:r>
+              <a:rPr lang="en-US" altLang="en-US" sz="900" b="1" dirty="0">
+                <a:solidFill>
+                  <a:srgbClr val="334153"/>
+                </a:solidFill>
+                <a:latin typeface="Raleway Regular" charset="0"/>
+                <a:cs typeface="Raleway Regular" charset="0"/>
+              </a:rPr>
+              <a:t>South Africa</a:t>
+            </a:r>
+            <a:r>
+              <a:rPr lang="en-US" altLang="en-US" sz="900" dirty="0">
+                <a:solidFill>
+                  <a:srgbClr val="334153"/>
+                </a:solidFill>
+                <a:latin typeface="Raleway Regular" charset="0"/>
+                <a:cs typeface="Raleway Regular" charset="0"/>
+              </a:rPr>
+              <a:t> (</a:t>
+            </a:r>
+            <a:r>
+              <a:rPr lang="en-US" altLang="en-US" sz="900" b="1" dirty="0">
+                <a:solidFill>
+                  <a:srgbClr val="334153"/>
+                </a:solidFill>
+                <a:latin typeface="Raleway Regular" charset="0"/>
+                <a:cs typeface="Raleway Regular" charset="0"/>
+              </a:rPr>
+              <a:t>54.03%</a:t>
+            </a:r>
+            <a:r>
+              <a:rPr lang="en-US" altLang="en-US" sz="900" dirty="0">
+                <a:solidFill>
+                  <a:srgbClr val="334153"/>
+                </a:solidFill>
+                <a:latin typeface="Raleway Regular" charset="0"/>
+                <a:cs typeface="Raleway Regular" charset="0"/>
+              </a:rPr>
+              <a:t>) exhibit robust engagement efficiency, suggesting high-intent audiences.</a:t>
             </a:r>
             <a:endParaRPr lang="en-US" altLang="en-US" sz="900" dirty="0">
               <a:solidFill>
@@ -6106,7 +6974,27 @@
                 <a:latin typeface="Raleway Regular" charset="0"/>
                 <a:cs typeface="Raleway Regular" charset="0"/>
               </a:rPr>
-              <a:t>Overall, Zimbabwe provides scale, while select international markets demonstrate strong engagement depth and potential conversion value.</a:t>
+              <a:t>In summary, </a:t>
+            </a:r>
+            <a:r>
+              <a:rPr lang="en-US" altLang="en-US" sz="900" b="1" dirty="0">
+                <a:solidFill>
+                  <a:srgbClr val="334153"/>
+                </a:solidFill>
+                <a:latin typeface="Raleway Regular" charset="0"/>
+                <a:cs typeface="Raleway Regular" charset="0"/>
+              </a:rPr>
+              <a:t>Zimbabwe</a:t>
+            </a:r>
+            <a:r>
+              <a:rPr lang="en-US" altLang="en-US" sz="900" dirty="0">
+                <a:solidFill>
+                  <a:srgbClr val="334153"/>
+                </a:solidFill>
+                <a:latin typeface="Raleway Regular" charset="0"/>
+                <a:cs typeface="Raleway Regular" charset="0"/>
+              </a:rPr>
+              <a:t> achieves scale, while specific international markets display robust engagement depth and potential conversion value.</a:t>
             </a:r>
             <a:endParaRPr lang="en-US" altLang="en-US" sz="900" dirty="0">
               <a:solidFill>
@@ -6243,7 +7131,7 @@
       </p:grpSp>
       <p:pic>
         <p:nvPicPr>
-          <p:cNvPr id="11" name="Picture 10" descr="Screenshot 2026-06-29 at 17.25.19"/>
+          <p:cNvPr id="10" name="Picture 9" descr="countries_table.png"/>
           <p:cNvPicPr>
             <a:picLocks noChangeAspect="1"/>
           </p:cNvPicPr>
@@ -6587,7 +7475,107 @@
                 <a:latin typeface="Raleway Regular" charset="0"/>
                 <a:cs typeface="Raleway Regular" charset="0"/>
               </a:rPr>
-              <a:t>Secondary pages such as Customer Support, Banking Accounts, and Personal Loans contribute meaningful traffic, but with more limited evidence of deep exploratory browsing.</a:t>
+              <a:t>The </a:t>
+            </a:r>
+            <a:r>
+              <a:rPr lang="en-US" altLang="en-US" sz="950" b="1" dirty="0">
+                <a:solidFill>
+                  <a:srgbClr val="334153"/>
+                </a:solidFill>
+                <a:latin typeface="Raleway Regular" charset="0"/>
+                <a:cs typeface="Raleway Regular" charset="0"/>
+              </a:rPr>
+              <a:t>Homepage</a:t>
+            </a:r>
+            <a:r>
+              <a:rPr lang="en-US" altLang="en-US" sz="950" dirty="0">
+                <a:solidFill>
+                  <a:srgbClr val="334153"/>
+                </a:solidFill>
+                <a:latin typeface="Raleway Regular" charset="0"/>
+                <a:cs typeface="Raleway Regular" charset="0"/>
+              </a:rPr>
+              <a:t> drives the highest traffic, accounting for </a:t>
+            </a:r>
+            <a:r>
+              <a:rPr lang="en-US" altLang="en-US" sz="950" b="1" dirty="0">
+                <a:solidFill>
+                  <a:srgbClr val="334153"/>
+                </a:solidFill>
+                <a:latin typeface="Raleway Regular" charset="0"/>
+                <a:cs typeface="Raleway Regular" charset="0"/>
+              </a:rPr>
+              <a:t>53.17%</a:t>
+            </a:r>
+            <a:r>
+              <a:rPr lang="en-US" altLang="en-US" sz="950" dirty="0">
+                <a:solidFill>
+                  <a:srgbClr val="334153"/>
+                </a:solidFill>
+                <a:latin typeface="Raleway Regular" charset="0"/>
+                <a:cs typeface="Raleway Regular" charset="0"/>
+              </a:rPr>
+              <a:t> of total views (</a:t>
+            </a:r>
+            <a:r>
+              <a:rPr lang="en-US" altLang="en-US" sz="950" b="1" dirty="0">
+                <a:solidFill>
+                  <a:srgbClr val="334153"/>
+                </a:solidFill>
+                <a:latin typeface="Raleway Regular" charset="0"/>
+                <a:cs typeface="Raleway Regular" charset="0"/>
+              </a:rPr>
+              <a:t>10,082</a:t>
+            </a:r>
+            <a:r>
+              <a:rPr lang="en-US" altLang="en-US" sz="950" dirty="0">
+                <a:solidFill>
+                  <a:srgbClr val="334153"/>
+                </a:solidFill>
+                <a:latin typeface="Raleway Regular" charset="0"/>
+                <a:cs typeface="Raleway Regular" charset="0"/>
+              </a:rPr>
+              <a:t> views), with </a:t>
+            </a:r>
+            <a:r>
+              <a:rPr lang="en-US" altLang="en-US" sz="950" b="1" dirty="0">
+                <a:solidFill>
+                  <a:srgbClr val="334153"/>
+                </a:solidFill>
+                <a:latin typeface="Raleway Regular" charset="0"/>
+                <a:cs typeface="Raleway Regular" charset="0"/>
+              </a:rPr>
+              <a:t>2.54</a:t>
+            </a:r>
+            <a:r>
+              <a:rPr lang="en-US" altLang="en-US" sz="950" dirty="0">
+                <a:solidFill>
+                  <a:srgbClr val="334153"/>
+                </a:solidFill>
+                <a:latin typeface="Raleway Regular" charset="0"/>
+                <a:cs typeface="Raleway Regular" charset="0"/>
+              </a:rPr>
+              <a:t> views per active user and an average engagement duration of </a:t>
+            </a:r>
+            <a:r>
+              <a:rPr lang="en-US" altLang="en-US" sz="950" b="1" dirty="0">
+                <a:solidFill>
+                  <a:srgbClr val="334153"/>
+                </a:solidFill>
+                <a:latin typeface="Raleway Regular" charset="0"/>
+                <a:cs typeface="Raleway Regular" charset="0"/>
+              </a:rPr>
+              <a:t>29s</a:t>
+            </a:r>
+            <a:r>
+              <a:rPr lang="en-US" altLang="en-US" sz="950" dirty="0">
+                <a:solidFill>
+                  <a:srgbClr val="334153"/>
+                </a:solidFill>
+                <a:latin typeface="Raleway Regular" charset="0"/>
+                <a:cs typeface="Raleway Regular" charset="0"/>
+              </a:rPr>
+              <a:t>. This substantial volume indicates strong content discoverability and user interest.</a:t>
             </a:r>
             <a:endParaRPr lang="en-US" altLang="en-US" sz="950" dirty="0">
               <a:solidFill>
@@ -6631,7 +7619,47 @@
                 <a:latin typeface="Raleway Regular" charset="0"/>
                 <a:cs typeface="Raleway Regular" charset="0"/>
               </a:rPr>
-              <a:t>The deepest engagement among key content pages is recorded on the Homepage (2.68 views per user) and Personal Loans (1.78 views per user), indicating stronger exploration intent and higher content value for those visitors.</a:t>
+              <a:t>Secondary pages such as </a:t>
+            </a:r>
+            <a:r>
+              <a:rPr lang="en-US" altLang="en-US" sz="950" b="1" dirty="0">
+                <a:solidFill>
+                  <a:srgbClr val="334153"/>
+                </a:solidFill>
+                <a:latin typeface="Raleway Regular" charset="0"/>
+                <a:cs typeface="Raleway Regular" charset="0"/>
+              </a:rPr>
+              <a:t>Contact Us</a:t>
+            </a:r>
+            <a:r>
+              <a:rPr lang="en-US" altLang="en-US" sz="950" dirty="0">
+                <a:solidFill>
+                  <a:srgbClr val="334153"/>
+                </a:solidFill>
+                <a:latin typeface="Raleway Regular" charset="0"/>
+                <a:cs typeface="Raleway Regular" charset="0"/>
+              </a:rPr>
+              <a:t> and </a:t>
+            </a:r>
+            <a:r>
+              <a:rPr lang="en-US" altLang="en-US" sz="950" b="1" dirty="0">
+                <a:solidFill>
+                  <a:srgbClr val="334153"/>
+                </a:solidFill>
+                <a:latin typeface="Raleway Regular" charset="0"/>
+                <a:cs typeface="Raleway Regular" charset="0"/>
+              </a:rPr>
+              <a:t>Personal Borrow</a:t>
+            </a:r>
+            <a:r>
+              <a:rPr lang="en-US" altLang="en-US" sz="950" dirty="0">
+                <a:solidFill>
+                  <a:srgbClr val="334153"/>
+                </a:solidFill>
+                <a:latin typeface="Raleway Regular" charset="0"/>
+                <a:cs typeface="Raleway Regular" charset="0"/>
+              </a:rPr>
+              <a:t> contribute meaningful traffic, but with more limited evidence of deep exploratory browsing.</a:t>
             </a:r>
             <a:endParaRPr lang="en-US" altLang="en-US" sz="950" dirty="0">
               <a:solidFill>
@@ -6645,7 +7673,7 @@
       </p:sp>
       <p:pic>
         <p:nvPicPr>
-          <p:cNvPr id="11" name="Picture 10" descr="Screenshot 2026-06-29 at 17.28.35"/>
+          <p:cNvPr id="7" name="Picture 6" descr="pages_table.png"/>
           <p:cNvPicPr>
             <a:picLocks noChangeAspect="1"/>
           </p:cNvPicPr>
@@ -6676,7 +7704,7 @@
 </file>
 
 <file path=ppt/slides/slide7.xml><?xml version="1.0" encoding="utf-8"?>
-<p:sld xmlns:a="http://schemas.openxmlformats.org/drawingml/2006/main" xmlns:p="http://schemas.openxmlformats.org/presentationml/2006/main" xmlns:r="http://schemas.openxmlformats.org/officeDocument/2006/relationships">
+<p:sld xmlns:a="http://schemas.openxmlformats.org/drawingml/2006/main" xmlns:r="http://schemas.openxmlformats.org/officeDocument/2006/relationships" xmlns:p="http://schemas.openxmlformats.org/presentationml/2006/main">
   <p:cSld>
     <p:spTree>
       <p:nvGrpSpPr>
@@ -6741,7 +7769,7 @@
         <p:spPr>
           <a:xfrm>
             <a:off x="428381" y="900929"/>
-            <a:ext cx="4219641" cy="319405"/>
+            <a:ext cx="4219641" cy="350520"/>
           </a:xfrm>
           <a:prstGeom prst="rect">
             <a:avLst/>
@@ -6761,7 +7789,27 @@
                 <a:spcPts val="95"/>
               </a:spcBef>
             </a:pPr>
-            <a:endParaRPr lang="en-US" altLang="en-GB" sz="1300" spc="-10">
+            <a:r>
+              <a:rPr lang="en-US" altLang="en-GB" sz="1100" spc="-10">
+                <a:solidFill>
+                  <a:srgbClr val="334154"/>
+                </a:solidFill>
+                <a:latin typeface="Raleway" pitchFamily="2" charset="77"/>
+                <a:cs typeface="Times New Roman" panose="02020603050405020304"/>
+              </a:rPr>
+              <a:t>Traffic Acquisition engagement was predominantly </a:t>
+            </a:r>
+            <a:r>
+              <a:rPr lang="en-US" altLang="en-GB" sz="1100" spc="-10">
+                <a:solidFill>
+                  <a:srgbClr val="334154"/>
+                </a:solidFill>
+                <a:latin typeface="Raleway" pitchFamily="2" charset="77"/>
+                <a:cs typeface="Times New Roman" panose="02020603050405020304"/>
+              </a:rPr>
+              <a:t>driven by google / organic at 50.78% and (direct) / (none) at 37.38%.</a:t>
+            </a:r>
+            <a:endParaRPr lang="en-US" altLang="en-GB" sz="1100" spc="-10">
               <a:solidFill>
                 <a:srgbClr val="334154"/>
               </a:solidFill>
@@ -6779,8 +7827,8 @@
         </p:nvGrpSpPr>
         <p:grpSpPr>
           <a:xfrm>
-            <a:off x="303792" y="1342200"/>
-            <a:ext cx="3311476" cy="3659820"/>
+            <a:off x="303530" y="1342390"/>
+            <a:ext cx="3739515" cy="3659505"/>
             <a:chOff x="429768" y="1090226"/>
             <a:chExt cx="3438525" cy="3907338"/>
           </a:xfrm>
@@ -6922,7 +7970,107 @@
             </a:endParaRPr>
           </a:p>
           <a:p>
-            <a:endParaRPr lang="en-US" altLang="en-US" sz="900" b="0">
+            <a:r>
+              <a:rPr lang="en-US" altLang="en-US" sz="900" b="1">
+                <a:solidFill>
+                  <a:schemeClr val="tx1"/>
+                </a:solidFill>
+                <a:latin typeface="Raleway" charset="0"/>
+                <a:cs typeface="Raleway" charset="0"/>
+              </a:rPr>
+              <a:t>google / organic</a:t>
+            </a:r>
+            <a:r>
+              <a:rPr lang="en-US" altLang="en-US" sz="900">
+                <a:solidFill>
+                  <a:schemeClr val="tx1"/>
+                </a:solidFill>
+                <a:latin typeface="Raleway" charset="0"/>
+                <a:cs typeface="Raleway" charset="0"/>
+              </a:rPr>
+              <a:t> led website acquisition with </a:t>
+            </a:r>
+            <a:r>
+              <a:rPr lang="en-US" altLang="en-US" sz="900" b="1">
+                <a:solidFill>
+                  <a:schemeClr val="tx1"/>
+                </a:solidFill>
+                <a:latin typeface="Raleway" charset="0"/>
+                <a:cs typeface="Raleway" charset="0"/>
+              </a:rPr>
+              <a:t>7,103</a:t>
+            </a:r>
+            <a:r>
+              <a:rPr lang="en-US" altLang="en-US" sz="900">
+                <a:solidFill>
+                  <a:schemeClr val="tx1"/>
+                </a:solidFill>
+                <a:latin typeface="Raleway" charset="0"/>
+                <a:cs typeface="Raleway" charset="0"/>
+              </a:rPr>
+              <a:t> sessions, representing </a:t>
+            </a:r>
+            <a:r>
+              <a:rPr lang="en-US" altLang="en-US" sz="900" b="1">
+                <a:solidFill>
+                  <a:schemeClr val="tx1"/>
+                </a:solidFill>
+                <a:latin typeface="Raleway" charset="0"/>
+                <a:cs typeface="Raleway" charset="0"/>
+              </a:rPr>
+              <a:t>50.78%</a:t>
+            </a:r>
+            <a:r>
+              <a:rPr lang="en-US" altLang="en-US" sz="900">
+                <a:solidFill>
+                  <a:schemeClr val="tx1"/>
+                </a:solidFill>
+                <a:latin typeface="Raleway" charset="0"/>
+                <a:cs typeface="Raleway" charset="0"/>
+              </a:rPr>
+              <a:t> of total. This source achieved a </a:t>
+            </a:r>
+            <a:r>
+              <a:rPr lang="en-US" altLang="en-US" sz="900" b="1">
+                <a:solidFill>
+                  <a:schemeClr val="tx1"/>
+                </a:solidFill>
+                <a:latin typeface="Raleway" charset="0"/>
+                <a:cs typeface="Raleway" charset="0"/>
+              </a:rPr>
+              <a:t>48.35%</a:t>
+            </a:r>
+            <a:r>
+              <a:rPr lang="en-US" altLang="en-US" sz="900">
+                <a:solidFill>
+                  <a:schemeClr val="tx1"/>
+                </a:solidFill>
+                <a:latin typeface="Raleway" charset="0"/>
+                <a:cs typeface="Raleway" charset="0"/>
+              </a:rPr>
+              <a:t> engagement rate and </a:t>
+            </a:r>
+            <a:r>
+              <a:rPr lang="en-US" altLang="en-US" sz="900" b="1">
+                <a:solidFill>
+                  <a:schemeClr val="tx1"/>
+                </a:solidFill>
+                <a:latin typeface="Raleway" charset="0"/>
+                <a:cs typeface="Raleway" charset="0"/>
+              </a:rPr>
+              <a:t>34s</a:t>
+            </a:r>
+            <a:r>
+              <a:rPr lang="en-US" altLang="en-US" sz="900">
+                <a:solidFill>
+                  <a:schemeClr val="tx1"/>
+                </a:solidFill>
+                <a:latin typeface="Raleway" charset="0"/>
+                <a:cs typeface="Raleway" charset="0"/>
+              </a:rPr>
+              <a:t> average engagement time.</a:t>
+            </a:r>
+            <a:endParaRPr lang="en-US" altLang="en-US" sz="900">
               <a:solidFill>
                 <a:schemeClr val="tx1"/>
               </a:solidFill>
@@ -6931,7 +8079,87 @@
             </a:endParaRPr>
           </a:p>
           <a:p>
-            <a:endParaRPr lang="en-US" altLang="en-US" sz="900" b="0">
+            <a:r>
+              <a:rPr lang="en-US" altLang="en-US" sz="900" b="1">
+                <a:solidFill>
+                  <a:schemeClr val="tx1"/>
+                </a:solidFill>
+                <a:latin typeface="Raleway" charset="0"/>
+                <a:cs typeface="Raleway" charset="0"/>
+              </a:rPr>
+              <a:t>(direct) / (none)</a:t>
+            </a:r>
+            <a:r>
+              <a:rPr lang="en-US" altLang="en-US" sz="900">
+                <a:solidFill>
+                  <a:schemeClr val="tx1"/>
+                </a:solidFill>
+                <a:latin typeface="Raleway" charset="0"/>
+                <a:cs typeface="Raleway" charset="0"/>
+              </a:rPr>
+              <a:t> is the second-largest source at </a:t>
+            </a:r>
+            <a:r>
+              <a:rPr lang="en-US" altLang="en-US" sz="900" b="1">
+                <a:solidFill>
+                  <a:schemeClr val="tx1"/>
+                </a:solidFill>
+                <a:latin typeface="Raleway" charset="0"/>
+                <a:cs typeface="Raleway" charset="0"/>
+              </a:rPr>
+              <a:t>5,229</a:t>
+            </a:r>
+            <a:r>
+              <a:rPr lang="en-US" altLang="en-US" sz="900">
+                <a:solidFill>
+                  <a:schemeClr val="tx1"/>
+                </a:solidFill>
+                <a:latin typeface="Raleway" charset="0"/>
+                <a:cs typeface="Raleway" charset="0"/>
+              </a:rPr>
+              <a:t> sessions, but its </a:t>
+            </a:r>
+            <a:r>
+              <a:rPr lang="en-US" altLang="en-US" sz="900" b="1">
+                <a:solidFill>
+                  <a:schemeClr val="tx1"/>
+                </a:solidFill>
+                <a:latin typeface="Raleway" charset="0"/>
+                <a:cs typeface="Raleway" charset="0"/>
+              </a:rPr>
+              <a:t>34.84%</a:t>
+            </a:r>
+            <a:r>
+              <a:rPr lang="en-US" altLang="en-US" sz="900">
+                <a:solidFill>
+                  <a:schemeClr val="tx1"/>
+                </a:solidFill>
+                <a:latin typeface="Raleway" charset="0"/>
+                <a:cs typeface="Raleway" charset="0"/>
+              </a:rPr>
+              <a:t> engagement rate and </a:t>
+            </a:r>
+            <a:r>
+              <a:rPr lang="en-US" altLang="en-US" sz="900" b="1">
+                <a:solidFill>
+                  <a:schemeClr val="tx1"/>
+                </a:solidFill>
+                <a:latin typeface="Raleway" charset="0"/>
+                <a:cs typeface="Raleway" charset="0"/>
+              </a:rPr>
+              <a:t>12s</a:t>
+            </a:r>
+            <a:r>
+              <a:rPr lang="en-US" altLang="en-US" sz="900">
+                <a:solidFill>
+                  <a:schemeClr val="tx1"/>
+                </a:solidFill>
+                <a:latin typeface="Raleway" charset="0"/>
+                <a:cs typeface="Raleway" charset="0"/>
+              </a:rPr>
+              <a:t> average engagement time signal limited engagement considering its traffic.</a:t>
+            </a:r>
+            <a:endParaRPr lang="en-US" altLang="en-US" sz="900">
               <a:solidFill>
                 <a:schemeClr val="tx1"/>
               </a:solidFill>
@@ -6940,7 +8168,97 @@
             </a:endParaRPr>
           </a:p>
           <a:p>
-            <a:endParaRPr lang="en-US" altLang="en-US" sz="900" b="0">
+            <a:r>
+              <a:rPr lang="en-US" altLang="en-US" sz="900">
+                <a:solidFill>
+                  <a:schemeClr val="tx1"/>
+                </a:solidFill>
+                <a:latin typeface="Raleway" charset="0"/>
+                <a:cs typeface="Raleway" charset="0"/>
+              </a:rPr>
+              <a:t>Organic search yielded high-quality traffic. </a:t>
+            </a:r>
+            <a:r>
+              <a:rPr lang="en-US" altLang="en-US" sz="900" b="1">
+                <a:solidFill>
+                  <a:schemeClr val="tx1"/>
+                </a:solidFill>
+                <a:latin typeface="Raleway" charset="0"/>
+                <a:cs typeface="Raleway" charset="0"/>
+              </a:rPr>
+              <a:t>google / organic</a:t>
+            </a:r>
+            <a:r>
+              <a:rPr lang="en-US" altLang="en-US" sz="900">
+                <a:solidFill>
+                  <a:schemeClr val="tx1"/>
+                </a:solidFill>
+                <a:latin typeface="Raleway" charset="0"/>
+                <a:cs typeface="Raleway" charset="0"/>
+              </a:rPr>
+              <a:t> registered a </a:t>
+            </a:r>
+            <a:r>
+              <a:rPr lang="en-US" altLang="en-US" sz="900" b="1">
+                <a:solidFill>
+                  <a:schemeClr val="tx1"/>
+                </a:solidFill>
+                <a:latin typeface="Raleway" charset="0"/>
+                <a:cs typeface="Raleway" charset="0"/>
+              </a:rPr>
+              <a:t>48.35%</a:t>
+            </a:r>
+            <a:r>
+              <a:rPr lang="en-US" altLang="en-US" sz="900">
+                <a:solidFill>
+                  <a:schemeClr val="tx1"/>
+                </a:solidFill>
+                <a:latin typeface="Raleway" charset="0"/>
+                <a:cs typeface="Raleway" charset="0"/>
+              </a:rPr>
+              <a:t> engagement rate, a </a:t>
+            </a:r>
+            <a:r>
+              <a:rPr lang="en-US" altLang="en-US" sz="900" b="1">
+                <a:solidFill>
+                  <a:schemeClr val="tx1"/>
+                </a:solidFill>
+                <a:latin typeface="Raleway" charset="0"/>
+                <a:cs typeface="Raleway" charset="0"/>
+              </a:rPr>
+              <a:t>34s</a:t>
+            </a:r>
+            <a:r>
+              <a:rPr lang="en-US" altLang="en-US" sz="900">
+                <a:solidFill>
+                  <a:schemeClr val="tx1"/>
+                </a:solidFill>
+                <a:latin typeface="Raleway" charset="0"/>
+                <a:cs typeface="Raleway" charset="0"/>
+              </a:rPr>
+              <a:t> average engagement time, and </a:t>
+            </a:r>
+            <a:r>
+              <a:rPr lang="en-US" altLang="en-US" sz="900" b="1">
+                <a:solidFill>
+                  <a:schemeClr val="tx1"/>
+                </a:solidFill>
+                <a:latin typeface="Raleway" charset="0"/>
+                <a:cs typeface="Raleway" charset="0"/>
+              </a:rPr>
+              <a:t>3.88</a:t>
+            </a:r>
+            <a:r>
+              <a:rPr lang="en-US" altLang="en-US" sz="900">
+                <a:solidFill>
+                  <a:schemeClr val="tx1"/>
+                </a:solidFill>
+                <a:latin typeface="Raleway" charset="0"/>
+                <a:cs typeface="Raleway" charset="0"/>
+              </a:rPr>
+              <a:t> events per session.</a:t>
+            </a:r>
+            <a:endParaRPr lang="en-US" altLang="en-US" sz="900">
               <a:solidFill>
                 <a:schemeClr val="tx1"/>
               </a:solidFill>
@@ -6949,7 +8267,77 @@
             </a:endParaRPr>
           </a:p>
           <a:p>
-            <a:endParaRPr lang="en-US" altLang="en-US" sz="900" b="0">
+            <a:r>
+              <a:rPr lang="en-US" altLang="en-US" sz="900">
+                <a:solidFill>
+                  <a:schemeClr val="tx1"/>
+                </a:solidFill>
+                <a:latin typeface="Raleway" charset="0"/>
+                <a:cs typeface="Raleway" charset="0"/>
+              </a:rPr>
+              <a:t>Overall, the website generated </a:t>
+            </a:r>
+            <a:r>
+              <a:rPr lang="en-US" altLang="en-US" sz="900" b="1">
+                <a:solidFill>
+                  <a:schemeClr val="tx1"/>
+                </a:solidFill>
+                <a:latin typeface="Raleway" charset="0"/>
+                <a:cs typeface="Raleway" charset="0"/>
+              </a:rPr>
+              <a:t>13,988</a:t>
+            </a:r>
+            <a:r>
+              <a:rPr lang="en-US" altLang="en-US" sz="900">
+                <a:solidFill>
+                  <a:schemeClr val="tx1"/>
+                </a:solidFill>
+                <a:latin typeface="Raleway" charset="0"/>
+                <a:cs typeface="Raleway" charset="0"/>
+              </a:rPr>
+              <a:t> sessions and </a:t>
+            </a:r>
+            <a:r>
+              <a:rPr lang="en-US" altLang="en-US" sz="900" b="1">
+                <a:solidFill>
+                  <a:schemeClr val="tx1"/>
+                </a:solidFill>
+                <a:latin typeface="Raleway" charset="0"/>
+                <a:cs typeface="Raleway" charset="0"/>
+              </a:rPr>
+              <a:t>5,940</a:t>
+            </a:r>
+            <a:r>
+              <a:rPr lang="en-US" altLang="en-US" sz="900">
+                <a:solidFill>
+                  <a:schemeClr val="tx1"/>
+                </a:solidFill>
+                <a:latin typeface="Raleway" charset="0"/>
+                <a:cs typeface="Raleway" charset="0"/>
+              </a:rPr>
+              <a:t> engaged sessions, with an overall engagement rate of </a:t>
+            </a:r>
+            <a:r>
+              <a:rPr lang="en-US" altLang="en-US" sz="900" b="1">
+                <a:solidFill>
+                  <a:schemeClr val="tx1"/>
+                </a:solidFill>
+                <a:latin typeface="Raleway" charset="0"/>
+                <a:cs typeface="Raleway" charset="0"/>
+              </a:rPr>
+              <a:t>42.46%</a:t>
+            </a:r>
+            <a:r>
+              <a:rPr lang="en-US" altLang="en-US" sz="900">
+                <a:solidFill>
+                  <a:schemeClr val="tx1"/>
+                </a:solidFill>
+                <a:latin typeface="Raleway" charset="0"/>
+                <a:cs typeface="Raleway" charset="0"/>
+              </a:rPr>
+              <a:t>. The channel mix outlines the key strengths in acquisition volume and engagement quality for the reporting period.</a:t>
+            </a:r>
+            <a:endParaRPr lang="en-US" altLang="en-US" sz="900">
               <a:solidFill>
                 <a:schemeClr val="tx1"/>
               </a:solidFill>
@@ -7109,14 +8497,14 @@
       </p:grpSp>
       <p:pic>
         <p:nvPicPr>
-          <p:cNvPr id="22" name="Picture 32" descr="image.png"/>
+          <p:cNvPr id="22" name="Picture 21" descr="traffic_acquisition_table.png"/>
           <p:cNvPicPr>
             <a:picLocks noChangeAspect="1"/>
           </p:cNvPicPr>
           <p:nvPr/>
         </p:nvPicPr>
         <p:blipFill>
-          <a:blip r:embed="rId2"/>
+          <a:blip r:embed="rId1"/>
           <a:stretch>
             <a:fillRect/>
           </a:stretch>
@@ -7164,7 +8552,7 @@
         </p:nvSpPr>
         <p:spPr>
           <a:xfrm>
-            <a:off x="428625" y="428866"/>
+            <a:off x="123825" y="428866"/>
             <a:ext cx="57150" cy="609600"/>
           </a:xfrm>
           <a:custGeom>
@@ -7221,7 +8609,7 @@
         </p:nvSpPr>
         <p:spPr>
           <a:xfrm>
-            <a:off x="631190" y="381000"/>
+            <a:off x="326390" y="381000"/>
             <a:ext cx="3839210" cy="335915"/>
           </a:xfrm>
           <a:prstGeom prst="rect">
@@ -7278,7 +8666,7 @@
         </p:nvSpPr>
         <p:spPr>
           <a:xfrm>
-            <a:off x="631507" y="783653"/>
+            <a:off x="326707" y="783653"/>
             <a:ext cx="3710940" cy="400050"/>
           </a:xfrm>
           <a:prstGeom prst="rect">
@@ -7307,27 +8695,7 @@
                 <a:latin typeface="Raleway Regular" charset="0"/>
                 <a:cs typeface="Raleway Regular" charset="0"/>
               </a:rPr>
-              <a:t>Strong Search Visibility with </a:t>
-            </a:r>
-            <a:r>
-              <a:rPr lang="en-US" altLang="en-US" sz="1250" dirty="0">
-                <a:solidFill>
-                  <a:srgbClr val="334153"/>
-                </a:solidFill>
-                <a:latin typeface="Raleway Regular" charset="0"/>
-                <a:cs typeface="Raleway Regular" charset="0"/>
-              </a:rPr>
-              <a:t>6.8</a:t>
-            </a:r>
-            <a:r>
-              <a:rPr sz="1250" dirty="0">
-                <a:solidFill>
-                  <a:srgbClr val="334153"/>
-                </a:solidFill>
-                <a:latin typeface="Raleway Regular" charset="0"/>
-                <a:cs typeface="Raleway Regular" charset="0"/>
-              </a:rPr>
-              <a:t>% Click-Through Rate</a:t>
+              <a:t>Achieved substantial search visibility with a 7.6% Click-Through Rate.</a:t>
             </a:r>
             <a:endParaRPr sz="1250" dirty="0">
               <a:solidFill>
@@ -7384,7 +8752,47 @@
                 <a:latin typeface="Raleway Regular" charset="0"/>
                 <a:cs typeface="Raleway Regular" charset="0"/>
               </a:rPr>
-              <a:t>With 94.2K impressions, the brand maintains substantial presence in search results, indicating strong keyword coverage and consistent discoverability. From this visibility, the site generated 6.36K clicks, reflecting meaningful traffic acquisition directly from search engines.</a:t>
+              <a:t>Attaining </a:t>
+            </a:r>
+            <a:r>
+              <a:rPr lang="en-US" altLang="en-US" sz="950" b="1" dirty="0">
+                <a:solidFill>
+                  <a:srgbClr val="334153"/>
+                </a:solidFill>
+                <a:latin typeface="Raleway Regular" charset="0"/>
+                <a:cs typeface="Raleway Regular" charset="0"/>
+              </a:rPr>
+              <a:t>84.1K</a:t>
+            </a:r>
+            <a:r>
+              <a:rPr lang="en-US" altLang="en-US" sz="950" dirty="0">
+                <a:solidFill>
+                  <a:srgbClr val="334153"/>
+                </a:solidFill>
+                <a:latin typeface="Raleway Regular" charset="0"/>
+                <a:cs typeface="Raleway Regular" charset="0"/>
+              </a:rPr>
+              <a:t> impressions, the brand demonstrates significant presence within search results, underscoring robust keyword coverage and sustained discoverability. This visibility yielded </a:t>
+            </a:r>
+            <a:r>
+              <a:rPr lang="en-US" altLang="en-US" sz="950" b="1" dirty="0">
+                <a:solidFill>
+                  <a:srgbClr val="334153"/>
+                </a:solidFill>
+                <a:latin typeface="Raleway Regular" charset="0"/>
+                <a:cs typeface="Raleway Regular" charset="0"/>
+              </a:rPr>
+              <a:t>6.37K</a:t>
+            </a:r>
+            <a:r>
+              <a:rPr lang="en-US" altLang="en-US" sz="950" dirty="0">
+                <a:solidFill>
+                  <a:srgbClr val="334153"/>
+                </a:solidFill>
+                <a:latin typeface="Raleway Regular" charset="0"/>
+                <a:cs typeface="Raleway Regular" charset="0"/>
+              </a:rPr>
+              <a:t> clicks, signifying valuable traffic acquisition originating directly from search engines.</a:t>
             </a:r>
             <a:endParaRPr lang="en-US" altLang="en-US" sz="950" dirty="0">
               <a:solidFill>
@@ -7428,7 +8836,27 @@
                 <a:latin typeface="Raleway Regular" charset="0"/>
                 <a:cs typeface="Raleway Regular" charset="0"/>
               </a:rPr>
-              <a:t>An average position of 7.9 is particularly encouraging, placing the website on the first page of search results for many queries. This reinforces strong SEO foundations and competitive ranking strength.</a:t>
+              <a:t>The </a:t>
+            </a:r>
+            <a:r>
+              <a:rPr lang="en-US" altLang="en-US" sz="950" b="1" dirty="0">
+                <a:solidFill>
+                  <a:srgbClr val="334153"/>
+                </a:solidFill>
+                <a:latin typeface="Raleway Regular" charset="0"/>
+                <a:cs typeface="Raleway Regular" charset="0"/>
+              </a:rPr>
+              <a:t>7.6%</a:t>
+            </a:r>
+            <a:r>
+              <a:rPr lang="en-US" altLang="en-US" sz="950" dirty="0">
+                <a:solidFill>
+                  <a:srgbClr val="334153"/>
+                </a:solidFill>
+                <a:latin typeface="Raleway Regular" charset="0"/>
+                <a:cs typeface="Raleway Regular" charset="0"/>
+              </a:rPr>
+              <a:t> click-through rate indicates strong impression-to-click conversion. This suggests compelling meta titles and descriptions that effectively resonate with searcher intent.</a:t>
             </a:r>
             <a:endParaRPr lang="en-US" altLang="en-US" sz="950" dirty="0">
               <a:solidFill>
@@ -7565,7 +8993,7 @@
       </p:grpSp>
       <p:pic>
         <p:nvPicPr>
-          <p:cNvPr id="10" name="Picture 9" descr="Screenshot 2026-06-29 at 17.31.29"/>
+          <p:cNvPr id="9" name="Picture 8" descr="search_console.png"/>
           <p:cNvPicPr>
             <a:picLocks noChangeAspect="1"/>
           </p:cNvPicPr>
@@ -7759,7 +9187,47 @@
                 <a:latin typeface="Raleway Regular" charset="0"/>
                 <a:cs typeface="Raleway Regular" charset="0"/>
               </a:rPr>
-              <a:t>Brand-driven searches dominate, with terms like “BancABC” (1284 clicks) and “Banc ABC” (393 clicks) leading performance, indicating strong brand recognition and direct user intent​​</a:t>
+              <a:t>The leading search queries were “bancabc” (</a:t>
+            </a:r>
+            <a:r>
+              <a:rPr lang="en-US" altLang="en-US" sz="1000" b="1" dirty="0">
+                <a:solidFill>
+                  <a:srgbClr val="334153"/>
+                </a:solidFill>
+                <a:latin typeface="Raleway Regular" charset="0"/>
+                <a:cs typeface="Raleway Regular" charset="0"/>
+              </a:rPr>
+              <a:t>1,391</a:t>
+            </a:r>
+            <a:r>
+              <a:rPr lang="en-US" altLang="en-US" sz="1000" dirty="0">
+                <a:solidFill>
+                  <a:srgbClr val="334153"/>
+                </a:solidFill>
+                <a:latin typeface="Raleway Regular" charset="0"/>
+                <a:cs typeface="Raleway Regular" charset="0"/>
+              </a:rPr>
+              <a:t> clicks) and “banc abc” (</a:t>
+            </a:r>
+            <a:r>
+              <a:rPr lang="en-US" altLang="en-US" sz="1000" b="1" dirty="0">
+                <a:solidFill>
+                  <a:srgbClr val="334153"/>
+                </a:solidFill>
+                <a:latin typeface="Raleway Regular" charset="0"/>
+                <a:cs typeface="Raleway Regular" charset="0"/>
+              </a:rPr>
+              <a:t>421</a:t>
+            </a:r>
+            <a:r>
+              <a:rPr lang="en-US" altLang="en-US" sz="1000" dirty="0">
+                <a:solidFill>
+                  <a:srgbClr val="334153"/>
+                </a:solidFill>
+                <a:latin typeface="Raleway Regular" charset="0"/>
+                <a:cs typeface="Raleway Regular" charset="0"/>
+              </a:rPr>
+              <a:t> clicks). These terms represent the strongest sources of organic search traffic during the reporting period.</a:t>
             </a:r>
             <a:endParaRPr lang="en-US" altLang="en-US" sz="1000" dirty="0">
               <a:solidFill>
@@ -7792,7 +9260,7 @@
       </p:sp>
       <p:pic>
         <p:nvPicPr>
-          <p:cNvPr id="2" name="Picture 1" descr="Screenshot 2026-06-29 at 17.32.55"/>
+          <p:cNvPr id="14" name="Picture 13" descr="top_queries.png"/>
           <p:cNvPicPr>
             <a:picLocks noChangeAspect="1"/>
           </p:cNvPicPr>

</xml_diff>